<commit_message>
Update Product Presentation Deck with Introduction and Technology Stack details
</commit_message>
<xml_diff>
--- a/ExpenseTracker_Product_Presentation.pptx
+++ b/ExpenseTracker_Product_Presentation.pptx
@@ -14,8 +14,9 @@
     <p:sldId id="262" r:id="rId13"/>
     <p:sldId id="263" r:id="rId14"/>
     <p:sldId id="264" r:id="rId15"/>
+    <p:sldId id="265" r:id="rId16"/>
   </p:sldIdLst>
-  <p:sldSz cx="12188952" cy="6858000" type="screen4x3"/>
+  <p:sldSz cx="12191695" cy="6858000" type="screen4x3"/>
   <p:notesSz cx="6858000" cy="9144000"/>
   <p:defaultTextStyle>
     <a:defPPr>
@@ -3092,7 +3093,7 @@
     <p:bg>
       <p:bgPr>
         <a:solidFill>
-          <a:srgbClr val="090D16"/>
+          <a:srgbClr val="0F172A"/>
         </a:solidFill>
         <a:effectLst/>
       </p:bgPr>
@@ -3106,180 +3107,14 @@
       <p:grpSpPr/>
       <p:sp>
         <p:nvSpPr>
-          <p:cNvPr id="2" name="TextBox 1"/>
-          <p:cNvSpPr txBox="1"/>
+          <p:cNvPr id="2" name="Rectangle 1"/>
+          <p:cNvSpPr/>
           <p:nvPr/>
         </p:nvSpPr>
         <p:spPr>
           <a:xfrm>
-            <a:off x="1371600" y="2011680"/>
-            <a:ext cx="9418320" cy="3200400"/>
-          </a:xfrm>
-          <a:prstGeom prst="rect">
-            <a:avLst/>
-          </a:prstGeom>
-          <a:noFill/>
-        </p:spPr>
-        <p:txBody>
-          <a:bodyPr wrap="square">
-            <a:spAutoFit/>
-          </a:bodyPr>
-          <a:lstStyle/>
-          <a:p>
-            <a:pPr algn="ctr">
-              <a:defRPr sz="5400" b="1">
-                <a:solidFill>
-                  <a:srgbClr val="10B981"/>
-                </a:solidFill>
-                <a:latin typeface="Trebuchet MS"/>
-              </a:defRPr>
-            </a:pPr>
-            <a:r>
-              <a:t>ExpenseTracker Suite</a:t>
-            </a:r>
-          </a:p>
-          <a:p>
-            <a:pPr algn="ctr">
-              <a:spcBef>
-                <a:spcPts val="1000"/>
-              </a:spcBef>
-              <a:defRPr sz="2000">
-                <a:solidFill>
-                  <a:srgbClr val="6366F1"/>
-                </a:solidFill>
-                <a:latin typeface="Calibri"/>
-              </a:defRPr>
-            </a:pPr>
-            <a:r>
-              <a:t>Next-Generation Premium Personal Finance &amp; Auditing Dashboard</a:t>
-            </a:r>
-          </a:p>
-          <a:p>
-            <a:pPr algn="ctr">
-              <a:spcBef>
-                <a:spcPts val="4000"/>
-              </a:spcBef>
-              <a:defRPr sz="1400">
-                <a:solidFill>
-                  <a:srgbClr val="94A3B8"/>
-                </a:solidFill>
-                <a:latin typeface="Calibri"/>
-              </a:defRPr>
-            </a:pPr>
-            <a:r>
-              <a:t>Product Features &amp; Technical Architecture Presentation</a:t>
-            </a:r>
-          </a:p>
-        </p:txBody>
-      </p:sp>
-    </p:spTree>
-  </p:cSld>
-  <p:clrMapOvr>
-    <a:masterClrMapping/>
-  </p:clrMapOvr>
-</p:sld>
-</file>
-
-<file path=ppt/slides/slide2.xml><?xml version="1.0" encoding="utf-8"?>
-<p:sld xmlns:a="http://schemas.openxmlformats.org/drawingml/2006/main" xmlns:p="http://schemas.openxmlformats.org/presentationml/2006/main" xmlns:r="http://schemas.openxmlformats.org/officeDocument/2006/relationships">
-  <p:cSld>
-    <p:bg>
-      <p:bgPr>
-        <a:solidFill>
-          <a:srgbClr val="090D16"/>
-        </a:solidFill>
-        <a:effectLst/>
-      </p:bgPr>
-    </p:bg>
-    <p:spTree>
-      <p:nvGrpSpPr>
-        <p:cNvPr id="1" name=""/>
-        <p:cNvGrpSpPr/>
-        <p:nvPr/>
-      </p:nvGrpSpPr>
-      <p:grpSpPr/>
-      <p:sp>
-        <p:nvSpPr>
-          <p:cNvPr id="2" name="TextBox 1"/>
-          <p:cNvSpPr txBox="1"/>
-          <p:nvPr/>
-        </p:nvSpPr>
-        <p:spPr>
-          <a:xfrm>
-            <a:off x="731520" y="365760"/>
-            <a:ext cx="10698480" cy="365760"/>
-          </a:xfrm>
-          <a:prstGeom prst="rect">
-            <a:avLst/>
-          </a:prstGeom>
-          <a:noFill/>
-        </p:spPr>
-        <p:txBody>
-          <a:bodyPr wrap="none">
-            <a:spAutoFit/>
-          </a:bodyPr>
-          <a:lstStyle/>
-          <a:p>
-            <a:pPr>
-              <a:defRPr sz="1100" b="1">
-                <a:solidFill>
-                  <a:srgbClr val="6366F1"/>
-                </a:solidFill>
-                <a:latin typeface="Trebuchet MS"/>
-              </a:defRPr>
-            </a:pPr>
-            <a:r>
-              <a:t>EXPENSETRACKER FEATURES</a:t>
-            </a:r>
-          </a:p>
-        </p:txBody>
-      </p:sp>
-      <p:sp>
-        <p:nvSpPr>
-          <p:cNvPr id="3" name="TextBox 2"/>
-          <p:cNvSpPr txBox="1"/>
-          <p:nvPr/>
-        </p:nvSpPr>
-        <p:spPr>
-          <a:xfrm>
-            <a:off x="731520" y="640080"/>
-            <a:ext cx="10698480" cy="731520"/>
-          </a:xfrm>
-          <a:prstGeom prst="rect">
-            <a:avLst/>
-          </a:prstGeom>
-          <a:noFill/>
-        </p:spPr>
-        <p:txBody>
-          <a:bodyPr wrap="none">
-            <a:spAutoFit/>
-          </a:bodyPr>
-          <a:lstStyle/>
-          <a:p>
-            <a:pPr>
-              <a:defRPr sz="2800" b="1">
-                <a:solidFill>
-                  <a:srgbClr val="F8FAFC"/>
-                </a:solidFill>
-                <a:latin typeface="Trebuchet MS"/>
-              </a:defRPr>
-            </a:pPr>
-            <a:r>
-              <a:t>Unified Financial Dashboard</a:t>
-            </a:r>
-          </a:p>
-        </p:txBody>
-      </p:sp>
-      <p:sp>
-        <p:nvSpPr>
-          <p:cNvPr id="4" name="Rectangle 3"/>
-          <p:cNvSpPr/>
-          <p:nvPr/>
-        </p:nvSpPr>
-        <p:spPr>
-          <a:xfrm>
-            <a:off x="731520" y="1371600"/>
-            <a:ext cx="10698480" cy="36576"/>
+            <a:off x="731520" y="2011680"/>
+            <a:ext cx="109728" cy="2743200"/>
           </a:xfrm>
           <a:prstGeom prst="rect">
             <a:avLst/>
@@ -3315,24 +3150,923 @@
       </p:sp>
       <p:sp>
         <p:nvSpPr>
-          <p:cNvPr id="5" name="Rectangle 4"/>
-          <p:cNvSpPr/>
+          <p:cNvPr id="3" name="TextBox 2"/>
+          <p:cNvSpPr txBox="1"/>
           <p:nvPr/>
         </p:nvSpPr>
         <p:spPr>
           <a:xfrm>
-            <a:off x="731520" y="1645920"/>
-            <a:ext cx="3291840" cy="4389120"/>
+            <a:off x="1097280" y="1920240"/>
+            <a:ext cx="10058400" cy="3200400"/>
           </a:xfrm>
           <a:prstGeom prst="rect">
             <a:avLst/>
           </a:prstGeom>
+          <a:noFill/>
+        </p:spPr>
+        <p:txBody>
+          <a:bodyPr wrap="square" lIns="0" tIns="0" rIns="0" bIns="0">
+            <a:spAutoFit/>
+          </a:bodyPr>
+          <a:lstStyle/>
+          <a:p>
+            <a:pPr>
+              <a:spcAft>
+                <a:spcPts val="800"/>
+              </a:spcAft>
+              <a:defRPr sz="5400" b="1">
+                <a:solidFill>
+                  <a:srgbClr val="F8FAFC"/>
+                </a:solidFill>
+                <a:latin typeface="Outfit"/>
+              </a:defRPr>
+            </a:pPr>
+            <a:r>
+              <a:t>ExpenseTracker</a:t>
+            </a:r>
+          </a:p>
+          <a:p>
+            <a:pPr>
+              <a:spcAft>
+                <a:spcPts val="2400"/>
+              </a:spcAft>
+              <a:defRPr sz="2200">
+                <a:solidFill>
+                  <a:srgbClr val="6366F1"/>
+                </a:solidFill>
+                <a:latin typeface="Inter"/>
+              </a:defRPr>
+            </a:pPr>
+            <a:r>
+              <a:t>Smart Personal Finance &amp; Analytics Platform</a:t>
+            </a:r>
+          </a:p>
+          <a:p>
+            <a:pPr>
+              <a:defRPr sz="1200">
+                <a:solidFill>
+                  <a:srgbClr val="94A3B8"/>
+                </a:solidFill>
+                <a:latin typeface="Inter"/>
+              </a:defRPr>
+            </a:pPr>
+            <a:r>
+              <a:t>A complete Flask, SQLAlchemy &amp; Chart.js Web Application Suite</a:t>
+            </a:r>
+            <a:br/>
+            <a:r>
+              <a:t>Designed by Shreya Sagar</a:t>
+            </a:r>
+          </a:p>
+        </p:txBody>
+      </p:sp>
+    </p:spTree>
+  </p:cSld>
+  <p:clrMapOvr>
+    <a:masterClrMapping/>
+  </p:clrMapOvr>
+</p:sld>
+</file>
+
+<file path=ppt/slides/slide10.xml><?xml version="1.0" encoding="utf-8"?>
+<p:sld xmlns:a="http://schemas.openxmlformats.org/drawingml/2006/main" xmlns:p="http://schemas.openxmlformats.org/presentationml/2006/main" xmlns:r="http://schemas.openxmlformats.org/officeDocument/2006/relationships">
+  <p:cSld>
+    <p:bg>
+      <p:bgPr>
+        <a:solidFill>
+          <a:srgbClr val="F8FAFC"/>
+        </a:solidFill>
+        <a:effectLst/>
+      </p:bgPr>
+    </p:bg>
+    <p:spTree>
+      <p:nvGrpSpPr>
+        <p:cNvPr id="1" name=""/>
+        <p:cNvGrpSpPr/>
+        <p:nvPr/>
+      </p:nvGrpSpPr>
+      <p:grpSpPr/>
+      <p:sp>
+        <p:nvSpPr>
+          <p:cNvPr id="2" name="TextBox 1"/>
+          <p:cNvSpPr txBox="1"/>
+          <p:nvPr/>
+        </p:nvSpPr>
+        <p:spPr>
+          <a:xfrm>
+            <a:off x="731520" y="457200"/>
+            <a:ext cx="10698480" cy="1097280"/>
+          </a:xfrm>
+          <a:prstGeom prst="rect">
+            <a:avLst/>
+          </a:prstGeom>
+          <a:noFill/>
+        </p:spPr>
+        <p:txBody>
+          <a:bodyPr wrap="square" lIns="0" tIns="0" rIns="0" bIns="0">
+            <a:spAutoFit/>
+          </a:bodyPr>
+          <a:lstStyle/>
+          <a:p>
+            <a:pPr>
+              <a:spcAft>
+                <a:spcPts val="400"/>
+              </a:spcAft>
+              <a:defRPr sz="1000" b="1">
+                <a:solidFill>
+                  <a:srgbClr val="6366F1"/>
+                </a:solidFill>
+                <a:latin typeface="Outfit"/>
+              </a:defRPr>
+            </a:pPr>
+            <a:r>
+              <a:t>09. DATA DESIGN &amp; FUTURE</a:t>
+            </a:r>
+          </a:p>
+          <a:p>
+            <a:pPr>
+              <a:defRPr sz="2800" b="1">
+                <a:solidFill>
+                  <a:srgbClr val="0F172A"/>
+                </a:solidFill>
+                <a:latin typeface="Outfit"/>
+              </a:defRPr>
+            </a:pPr>
+            <a:r>
+              <a:t>Database Architecture &amp; Future Roadmap</a:t>
+            </a:r>
+          </a:p>
+        </p:txBody>
+      </p:sp>
+      <p:sp>
+        <p:nvSpPr>
+          <p:cNvPr id="3" name="TextBox 2"/>
+          <p:cNvSpPr txBox="1"/>
+          <p:nvPr/>
+        </p:nvSpPr>
+        <p:spPr>
+          <a:xfrm>
+            <a:off x="731520" y="1828800"/>
+            <a:ext cx="5120640" cy="4114800"/>
+          </a:xfrm>
+          <a:prstGeom prst="rect">
+            <a:avLst/>
+          </a:prstGeom>
+          <a:noFill/>
+        </p:spPr>
+        <p:txBody>
+          <a:bodyPr wrap="square">
+            <a:spAutoFit/>
+          </a:bodyPr>
+          <a:lstStyle/>
+          <a:p>
+            <a:pPr>
+              <a:spcAft>
+                <a:spcPts val="1200"/>
+              </a:spcAft>
+              <a:defRPr sz="1800" b="1">
+                <a:solidFill>
+                  <a:srgbClr val="6366F1"/>
+                </a:solidFill>
+                <a:latin typeface="Outfit"/>
+              </a:defRPr>
+            </a:pPr>
+            <a:r>
+              <a:t>Relational Schema Model</a:t>
+            </a:r>
+          </a:p>
+          <a:p>
+            <a:pPr>
+              <a:spcAft>
+                <a:spcPts val="800"/>
+              </a:spcAft>
+              <a:defRPr sz="1100">
+                <a:solidFill>
+                  <a:srgbClr val="64748B"/>
+                </a:solidFill>
+                <a:latin typeface="Inter"/>
+              </a:defRPr>
+            </a:pPr>
+            <a:r>
+              <a:t>•  User Table: IDs, credentials, profile pictures, localizations, and customized alert thresholds.</a:t>
+            </a:r>
+          </a:p>
+          <a:p>
+            <a:pPr>
+              <a:spcAft>
+                <a:spcPts val="800"/>
+              </a:spcAft>
+              <a:defRPr sz="1100">
+                <a:solidFill>
+                  <a:srgbClr val="64748B"/>
+                </a:solidFill>
+                <a:latin typeface="Inter"/>
+              </a:defRPr>
+            </a:pPr>
+            <a:r>
+              <a:t>•  Transaction Table: Relates to User. Stores dates, amounts, categories, descriptions, types, and receipt images.</a:t>
+            </a:r>
+          </a:p>
+          <a:p>
+            <a:pPr>
+              <a:spcAft>
+                <a:spcPts val="800"/>
+              </a:spcAft>
+              <a:defRPr sz="1100">
+                <a:solidFill>
+                  <a:srgbClr val="64748B"/>
+                </a:solidFill>
+                <a:latin typeface="Inter"/>
+              </a:defRPr>
+            </a:pPr>
+            <a:r>
+              <a:t>•  Budget Table: Tracks custom category limits mapped dynamically by month.</a:t>
+            </a:r>
+          </a:p>
+          <a:p>
+            <a:pPr>
+              <a:spcAft>
+                <a:spcPts val="800"/>
+              </a:spcAft>
+              <a:defRPr sz="1100">
+                <a:solidFill>
+                  <a:srgbClr val="64748B"/>
+                </a:solidFill>
+                <a:latin typeface="Inter"/>
+              </a:defRPr>
+            </a:pPr>
+            <a:r>
+              <a:t>•  CustomCategory Table: Dynamic categories configured by individual users.</a:t>
+            </a:r>
+          </a:p>
+        </p:txBody>
+      </p:sp>
+      <p:sp>
+        <p:nvSpPr>
+          <p:cNvPr id="4" name="TextBox 3"/>
+          <p:cNvSpPr txBox="1"/>
+          <p:nvPr/>
+        </p:nvSpPr>
+        <p:spPr>
+          <a:xfrm>
+            <a:off x="6217920" y="1828800"/>
+            <a:ext cx="5120640" cy="4114800"/>
+          </a:xfrm>
+          <a:prstGeom prst="rect">
+            <a:avLst/>
+          </a:prstGeom>
+          <a:noFill/>
+        </p:spPr>
+        <p:txBody>
+          <a:bodyPr wrap="square">
+            <a:spAutoFit/>
+          </a:bodyPr>
+          <a:lstStyle/>
+          <a:p>
+            <a:pPr>
+              <a:spcAft>
+                <a:spcPts val="1200"/>
+              </a:spcAft>
+              <a:defRPr sz="1800" b="1">
+                <a:solidFill>
+                  <a:srgbClr val="10B981"/>
+                </a:solidFill>
+                <a:latin typeface="Outfit"/>
+              </a:defRPr>
+            </a:pPr>
+            <a:r>
+              <a:t>Future Project Roadmap</a:t>
+            </a:r>
+          </a:p>
+          <a:p>
+            <a:pPr>
+              <a:spcAft>
+                <a:spcPts val="1000"/>
+              </a:spcAft>
+              <a:defRPr sz="1150">
+                <a:solidFill>
+                  <a:srgbClr val="64748B"/>
+                </a:solidFill>
+                <a:latin typeface="Inter"/>
+              </a:defRPr>
+            </a:pPr>
+            <a:r>
+              <a:t>★  AI-Powered Audits: Automatic categorization of uploaded receipts via OCR image text analysis.</a:t>
+            </a:r>
+          </a:p>
+          <a:p>
+            <a:pPr>
+              <a:spcAft>
+                <a:spcPts val="1000"/>
+              </a:spcAft>
+              <a:defRPr sz="1150">
+                <a:solidFill>
+                  <a:srgbClr val="64748B"/>
+                </a:solidFill>
+                <a:latin typeface="Inter"/>
+              </a:defRPr>
+            </a:pPr>
+            <a:r>
+              <a:t>★  Bank Sync Integration: Automatic feeds loading transactions safely via secure Open Banking APIs.</a:t>
+            </a:r>
+          </a:p>
+          <a:p>
+            <a:pPr>
+              <a:spcAft>
+                <a:spcPts val="1000"/>
+              </a:spcAft>
+              <a:defRPr sz="1150">
+                <a:solidFill>
+                  <a:srgbClr val="64748B"/>
+                </a:solidFill>
+                <a:latin typeface="Inter"/>
+              </a:defRPr>
+            </a:pPr>
+            <a:r>
+              <a:t>★  Predictive Alerts: AI models forecasting cashflow changes and warning of potential budget breaches in advance.</a:t>
+            </a:r>
+          </a:p>
+        </p:txBody>
+      </p:sp>
+    </p:spTree>
+  </p:cSld>
+  <p:clrMapOvr>
+    <a:masterClrMapping/>
+  </p:clrMapOvr>
+</p:sld>
+</file>
+
+<file path=ppt/slides/slide2.xml><?xml version="1.0" encoding="utf-8"?>
+<p:sld xmlns:a="http://schemas.openxmlformats.org/drawingml/2006/main" xmlns:p="http://schemas.openxmlformats.org/presentationml/2006/main" xmlns:r="http://schemas.openxmlformats.org/officeDocument/2006/relationships">
+  <p:cSld>
+    <p:bg>
+      <p:bgPr>
+        <a:solidFill>
+          <a:srgbClr val="F8FAFC"/>
+        </a:solidFill>
+        <a:effectLst/>
+      </p:bgPr>
+    </p:bg>
+    <p:spTree>
+      <p:nvGrpSpPr>
+        <p:cNvPr id="1" name=""/>
+        <p:cNvGrpSpPr/>
+        <p:nvPr/>
+      </p:nvGrpSpPr>
+      <p:grpSpPr/>
+      <p:sp>
+        <p:nvSpPr>
+          <p:cNvPr id="2" name="TextBox 1"/>
+          <p:cNvSpPr txBox="1"/>
+          <p:nvPr/>
+        </p:nvSpPr>
+        <p:spPr>
+          <a:xfrm>
+            <a:off x="731520" y="457200"/>
+            <a:ext cx="10698480" cy="1097280"/>
+          </a:xfrm>
+          <a:prstGeom prst="rect">
+            <a:avLst/>
+          </a:prstGeom>
+          <a:noFill/>
+        </p:spPr>
+        <p:txBody>
+          <a:bodyPr wrap="square" lIns="0" tIns="0" rIns="0" bIns="0">
+            <a:spAutoFit/>
+          </a:bodyPr>
+          <a:lstStyle/>
+          <a:p>
+            <a:pPr>
+              <a:spcAft>
+                <a:spcPts val="400"/>
+              </a:spcAft>
+              <a:defRPr sz="1000" b="1">
+                <a:solidFill>
+                  <a:srgbClr val="6366F1"/>
+                </a:solidFill>
+                <a:latin typeface="Outfit"/>
+              </a:defRPr>
+            </a:pPr>
+            <a:r>
+              <a:t>01. EXECUTIVE SUMMARY</a:t>
+            </a:r>
+          </a:p>
+          <a:p>
+            <a:pPr>
+              <a:defRPr sz="2800" b="1">
+                <a:solidFill>
+                  <a:srgbClr val="0F172A"/>
+                </a:solidFill>
+                <a:latin typeface="Outfit"/>
+              </a:defRPr>
+            </a:pPr>
+            <a:r>
+              <a:t>Introduction &amp; Overview</a:t>
+            </a:r>
+          </a:p>
+        </p:txBody>
+      </p:sp>
+      <p:sp>
+        <p:nvSpPr>
+          <p:cNvPr id="3" name="TextBox 2"/>
+          <p:cNvSpPr txBox="1"/>
+          <p:nvPr/>
+        </p:nvSpPr>
+        <p:spPr>
+          <a:xfrm>
+            <a:off x="731520" y="1828800"/>
+            <a:ext cx="10698480" cy="4114800"/>
+          </a:xfrm>
+          <a:prstGeom prst="rect">
+            <a:avLst/>
+          </a:prstGeom>
+          <a:noFill/>
+        </p:spPr>
+        <p:txBody>
+          <a:bodyPr wrap="square">
+            <a:spAutoFit/>
+          </a:bodyPr>
+          <a:lstStyle/>
+          <a:p>
+            <a:pPr>
+              <a:spcAft>
+                <a:spcPts val="2000"/>
+              </a:spcAft>
+              <a:defRPr sz="1600">
+                <a:solidFill>
+                  <a:srgbClr val="0F172A"/>
+                </a:solidFill>
+                <a:latin typeface="Inter"/>
+              </a:defRPr>
+            </a:pPr>
+            <a:r>
+              <a:t>ExpenseTracker is a comprehensive, premium web application built to help users manage their financial health. By combining transactional logging with dynamic visualization tools, the application offers an end-to-end sandbox for personal asset management.</a:t>
+            </a:r>
+          </a:p>
+          <a:p>
+            <a:pPr>
+              <a:spcAft>
+                <a:spcPts val="1000"/>
+              </a:spcAft>
+              <a:defRPr sz="1800" b="1">
+                <a:solidFill>
+                  <a:srgbClr val="6366F1"/>
+                </a:solidFill>
+                <a:latin typeface="Outfit"/>
+              </a:defRPr>
+            </a:pPr>
+            <a:r>
+              <a:t>Core Value Propositions:</a:t>
+            </a:r>
+          </a:p>
+          <a:p>
+            <a:pPr>
+              <a:spcAft>
+                <a:spcPts val="800"/>
+              </a:spcAft>
+              <a:defRPr sz="1300">
+                <a:solidFill>
+                  <a:srgbClr val="64748B"/>
+                </a:solidFill>
+                <a:latin typeface="Inter"/>
+              </a:defRPr>
+            </a:pPr>
+            <a:r>
+              <a:t>•  Interactive Dashboards: Real-time calculation of net balance, total income, and category distributions.</a:t>
+            </a:r>
+          </a:p>
+          <a:p>
+            <a:pPr>
+              <a:spcAft>
+                <a:spcPts val="800"/>
+              </a:spcAft>
+              <a:defRPr sz="1300">
+                <a:solidFill>
+                  <a:srgbClr val="64748B"/>
+                </a:solidFill>
+                <a:latin typeface="Inter"/>
+              </a:defRPr>
+            </a:pPr>
+            <a:r>
+              <a:t>•  Granular Personalization: Tailor app currencies, custom warning alert thresholds, and language preferences dynamically.</a:t>
+            </a:r>
+          </a:p>
+          <a:p>
+            <a:pPr>
+              <a:spcAft>
+                <a:spcPts val="800"/>
+              </a:spcAft>
+              <a:defRPr sz="1300">
+                <a:solidFill>
+                  <a:srgbClr val="64748B"/>
+                </a:solidFill>
+                <a:latin typeface="Inter"/>
+              </a:defRPr>
+            </a:pPr>
+            <a:r>
+              <a:t>•  Secure Storage: Password hashing protection, user session isolation, and secure local receipt image attachments.</a:t>
+            </a:r>
+          </a:p>
+          <a:p>
+            <a:pPr>
+              <a:spcAft>
+                <a:spcPts val="800"/>
+              </a:spcAft>
+              <a:defRPr sz="1300">
+                <a:solidFill>
+                  <a:srgbClr val="64748B"/>
+                </a:solidFill>
+                <a:latin typeface="Inter"/>
+              </a:defRPr>
+            </a:pPr>
+            <a:r>
+              <a:t>•  Double-Quoted Statements Exporter: Export monthly statements into CSV, ReportLab PDF, or python-pptx PowerPoint formats.</a:t>
+            </a:r>
+          </a:p>
+        </p:txBody>
+      </p:sp>
+    </p:spTree>
+  </p:cSld>
+  <p:clrMapOvr>
+    <a:masterClrMapping/>
+  </p:clrMapOvr>
+</p:sld>
+</file>
+
+<file path=ppt/slides/slide3.xml><?xml version="1.0" encoding="utf-8"?>
+<p:sld xmlns:a="http://schemas.openxmlformats.org/drawingml/2006/main" xmlns:p="http://schemas.openxmlformats.org/presentationml/2006/main" xmlns:r="http://schemas.openxmlformats.org/officeDocument/2006/relationships">
+  <p:cSld>
+    <p:bg>
+      <p:bgPr>
+        <a:solidFill>
+          <a:srgbClr val="0F172A"/>
+        </a:solidFill>
+        <a:effectLst/>
+      </p:bgPr>
+    </p:bg>
+    <p:spTree>
+      <p:nvGrpSpPr>
+        <p:cNvPr id="1" name=""/>
+        <p:cNvGrpSpPr/>
+        <p:nvPr/>
+      </p:nvGrpSpPr>
+      <p:grpSpPr/>
+      <p:sp>
+        <p:nvSpPr>
+          <p:cNvPr id="2" name="TextBox 1"/>
+          <p:cNvSpPr txBox="1"/>
+          <p:nvPr/>
+        </p:nvSpPr>
+        <p:spPr>
+          <a:xfrm>
+            <a:off x="731520" y="457200"/>
+            <a:ext cx="10698480" cy="1097280"/>
+          </a:xfrm>
+          <a:prstGeom prst="rect">
+            <a:avLst/>
+          </a:prstGeom>
+          <a:noFill/>
+        </p:spPr>
+        <p:txBody>
+          <a:bodyPr wrap="square" lIns="0" tIns="0" rIns="0" bIns="0">
+            <a:spAutoFit/>
+          </a:bodyPr>
+          <a:lstStyle/>
+          <a:p>
+            <a:pPr>
+              <a:spcAft>
+                <a:spcPts val="400"/>
+              </a:spcAft>
+              <a:defRPr sz="1000" b="1">
+                <a:solidFill>
+                  <a:srgbClr val="10B981"/>
+                </a:solidFill>
+                <a:latin typeface="Outfit"/>
+              </a:defRPr>
+            </a:pPr>
+            <a:r>
+              <a:t>02. TECHNICAL ARCHITECTURE</a:t>
+            </a:r>
+          </a:p>
+          <a:p>
+            <a:pPr>
+              <a:defRPr sz="2800" b="1">
+                <a:solidFill>
+                  <a:srgbClr val="F8FAFC"/>
+                </a:solidFill>
+                <a:latin typeface="Outfit"/>
+              </a:defRPr>
+            </a:pPr>
+            <a:r>
+              <a:t>Technology Stack Configuration</a:t>
+            </a:r>
+          </a:p>
+        </p:txBody>
+      </p:sp>
+      <p:sp>
+        <p:nvSpPr>
+          <p:cNvPr id="3" name="TextBox 2"/>
+          <p:cNvSpPr txBox="1"/>
+          <p:nvPr/>
+        </p:nvSpPr>
+        <p:spPr>
+          <a:xfrm>
+            <a:off x="731520" y="1828800"/>
+            <a:ext cx="5120640" cy="4114800"/>
+          </a:xfrm>
+          <a:prstGeom prst="rect">
+            <a:avLst/>
+          </a:prstGeom>
+          <a:noFill/>
+        </p:spPr>
+        <p:txBody>
+          <a:bodyPr wrap="square">
+            <a:spAutoFit/>
+          </a:bodyPr>
+          <a:lstStyle/>
+          <a:p>
+            <a:pPr>
+              <a:spcAft>
+                <a:spcPts val="1200"/>
+              </a:spcAft>
+              <a:defRPr sz="1800" b="1">
+                <a:solidFill>
+                  <a:srgbClr val="10B981"/>
+                </a:solidFill>
+                <a:latin typeface="Outfit"/>
+              </a:defRPr>
+            </a:pPr>
+            <a:r>
+              <a:t>Backend Framework &amp; Core</a:t>
+            </a:r>
+          </a:p>
+          <a:p>
+            <a:pPr>
+              <a:spcAft>
+                <a:spcPts val="1000"/>
+              </a:spcAft>
+              <a:defRPr sz="1200">
+                <a:solidFill>
+                  <a:srgbClr val="94A3B8"/>
+                </a:solidFill>
+                <a:latin typeface="Inter"/>
+              </a:defRPr>
+            </a:pPr>
+            <a:r>
+              <a:t>▪  Flask (v3.0.3) - Lightweight, modular WSGI web application framework for routing and session controllers.</a:t>
+            </a:r>
+          </a:p>
+          <a:p>
+            <a:pPr>
+              <a:spcAft>
+                <a:spcPts val="1000"/>
+              </a:spcAft>
+              <a:defRPr sz="1200">
+                <a:solidFill>
+                  <a:srgbClr val="94A3B8"/>
+                </a:solidFill>
+                <a:latin typeface="Inter"/>
+              </a:defRPr>
+            </a:pPr>
+            <a:r>
+              <a:t>▪  SQLAlchemy ORM - Abstracted SQLite database access mapping relational objects to clean python classes.</a:t>
+            </a:r>
+          </a:p>
+          <a:p>
+            <a:pPr>
+              <a:spcAft>
+                <a:spcPts val="1000"/>
+              </a:spcAft>
+              <a:defRPr sz="1200">
+                <a:solidFill>
+                  <a:srgbClr val="94A3B8"/>
+                </a:solidFill>
+                <a:latin typeface="Inter"/>
+              </a:defRPr>
+            </a:pPr>
+            <a:r>
+              <a:t>▪  Flask-Login - Managed secure user login state, session cookies, and route protection rules.</a:t>
+            </a:r>
+          </a:p>
+          <a:p>
+            <a:pPr>
+              <a:spcAft>
+                <a:spcPts val="1000"/>
+              </a:spcAft>
+              <a:defRPr sz="1200">
+                <a:solidFill>
+                  <a:srgbClr val="94A3B8"/>
+                </a:solidFill>
+                <a:latin typeface="Inter"/>
+              </a:defRPr>
+            </a:pPr>
+            <a:r>
+              <a:t>▪  Werkzeug - Secure password cryptography hashing and local receipt image filename sanitizations.</a:t>
+            </a:r>
+          </a:p>
+        </p:txBody>
+      </p:sp>
+      <p:sp>
+        <p:nvSpPr>
+          <p:cNvPr id="4" name="TextBox 3"/>
+          <p:cNvSpPr txBox="1"/>
+          <p:nvPr/>
+        </p:nvSpPr>
+        <p:spPr>
+          <a:xfrm>
+            <a:off x="6217920" y="1828800"/>
+            <a:ext cx="5120640" cy="4114800"/>
+          </a:xfrm>
+          <a:prstGeom prst="rect">
+            <a:avLst/>
+          </a:prstGeom>
+          <a:noFill/>
+        </p:spPr>
+        <p:txBody>
+          <a:bodyPr wrap="square">
+            <a:spAutoFit/>
+          </a:bodyPr>
+          <a:lstStyle/>
+          <a:p>
+            <a:pPr>
+              <a:spcAft>
+                <a:spcPts val="1200"/>
+              </a:spcAft>
+              <a:defRPr sz="1800" b="1">
+                <a:solidFill>
+                  <a:srgbClr val="6366F1"/>
+                </a:solidFill>
+                <a:latin typeface="Outfit"/>
+              </a:defRPr>
+            </a:pPr>
+            <a:r>
+              <a:t>Frontend, Charts &amp; Exporters</a:t>
+            </a:r>
+          </a:p>
+          <a:p>
+            <a:pPr>
+              <a:spcAft>
+                <a:spcPts val="1000"/>
+              </a:spcAft>
+              <a:defRPr sz="1200">
+                <a:solidFill>
+                  <a:srgbClr val="94A3B8"/>
+                </a:solidFill>
+                <a:latin typeface="Inter"/>
+              </a:defRPr>
+            </a:pPr>
+            <a:r>
+              <a:t>▪  Bootstrap 5 - Premium utility structure, dynamic layouts, grid templates, and interactive modal sheets.</a:t>
+            </a:r>
+          </a:p>
+          <a:p>
+            <a:pPr>
+              <a:spcAft>
+                <a:spcPts val="1000"/>
+              </a:spcAft>
+              <a:defRPr sz="1200">
+                <a:solidFill>
+                  <a:srgbClr val="94A3B8"/>
+                </a:solidFill>
+                <a:latin typeface="Inter"/>
+              </a:defRPr>
+            </a:pPr>
+            <a:r>
+              <a:t>▪  Chart.js - Client-side HTML5 canvas doughnut and bar visualization for category and monthly spends.</a:t>
+            </a:r>
+          </a:p>
+          <a:p>
+            <a:pPr>
+              <a:spcAft>
+                <a:spcPts val="1000"/>
+              </a:spcAft>
+              <a:defRPr sz="1200">
+                <a:solidFill>
+                  <a:srgbClr val="94A3B8"/>
+                </a:solidFill>
+                <a:latin typeface="Inter"/>
+              </a:defRPr>
+            </a:pPr>
+            <a:r>
+              <a:t>▪  ReportLab PDF - Server-side rendering flowables generating secure, double-quoted statements.</a:t>
+            </a:r>
+          </a:p>
+          <a:p>
+            <a:pPr>
+              <a:spcAft>
+                <a:spcPts val="1000"/>
+              </a:spcAft>
+              <a:defRPr sz="1200">
+                <a:solidFill>
+                  <a:srgbClr val="94A3B8"/>
+                </a:solidFill>
+                <a:latin typeface="Inter"/>
+              </a:defRPr>
+            </a:pPr>
+            <a:r>
+              <a:t>▪  python-pptx - Dynamic presentation slides compiler converting monthly database stats to widescreen PPTX downloads.</a:t>
+            </a:r>
+          </a:p>
+        </p:txBody>
+      </p:sp>
+    </p:spTree>
+  </p:cSld>
+  <p:clrMapOvr>
+    <a:masterClrMapping/>
+  </p:clrMapOvr>
+</p:sld>
+</file>
+
+<file path=ppt/slides/slide4.xml><?xml version="1.0" encoding="utf-8"?>
+<p:sld xmlns:a="http://schemas.openxmlformats.org/drawingml/2006/main" xmlns:p="http://schemas.openxmlformats.org/presentationml/2006/main" xmlns:r="http://schemas.openxmlformats.org/officeDocument/2006/relationships">
+  <p:cSld>
+    <p:bg>
+      <p:bgPr>
+        <a:solidFill>
+          <a:srgbClr val="F8FAFC"/>
+        </a:solidFill>
+        <a:effectLst/>
+      </p:bgPr>
+    </p:bg>
+    <p:spTree>
+      <p:nvGrpSpPr>
+        <p:cNvPr id="1" name=""/>
+        <p:cNvGrpSpPr/>
+        <p:nvPr/>
+      </p:nvGrpSpPr>
+      <p:grpSpPr/>
+      <p:sp>
+        <p:nvSpPr>
+          <p:cNvPr id="2" name="TextBox 1"/>
+          <p:cNvSpPr txBox="1"/>
+          <p:nvPr/>
+        </p:nvSpPr>
+        <p:spPr>
+          <a:xfrm>
+            <a:off x="731520" y="457200"/>
+            <a:ext cx="10698480" cy="1097280"/>
+          </a:xfrm>
+          <a:prstGeom prst="rect">
+            <a:avLst/>
+          </a:prstGeom>
+          <a:noFill/>
+        </p:spPr>
+        <p:txBody>
+          <a:bodyPr wrap="square" lIns="0" tIns="0" rIns="0" bIns="0">
+            <a:spAutoFit/>
+          </a:bodyPr>
+          <a:lstStyle/>
+          <a:p>
+            <a:pPr>
+              <a:spcAft>
+                <a:spcPts val="400"/>
+              </a:spcAft>
+              <a:defRPr sz="1000" b="1">
+                <a:solidFill>
+                  <a:srgbClr val="6366F1"/>
+                </a:solidFill>
+                <a:latin typeface="Outfit"/>
+              </a:defRPr>
+            </a:pPr>
+            <a:r>
+              <a:t>03. PRESENTATION ROADMAP</a:t>
+            </a:r>
+          </a:p>
+          <a:p>
+            <a:pPr>
+              <a:defRPr sz="2800" b="1">
+                <a:solidFill>
+                  <a:srgbClr val="0F172A"/>
+                </a:solidFill>
+                <a:latin typeface="Outfit"/>
+              </a:defRPr>
+            </a:pPr>
+            <a:r>
+              <a:t>Table of Contents</a:t>
+            </a:r>
+          </a:p>
+        </p:txBody>
+      </p:sp>
+      <p:sp>
+        <p:nvSpPr>
+          <p:cNvPr id="3" name="Rounded Rectangle 2"/>
+          <p:cNvSpPr/>
+          <p:nvPr/>
+        </p:nvSpPr>
+        <p:spPr>
+          <a:xfrm>
+            <a:off x="731520" y="1828800"/>
+            <a:ext cx="3383280" cy="1920240"/>
+          </a:xfrm>
+          <a:prstGeom prst="roundRect">
+            <a:avLst/>
+          </a:prstGeom>
           <a:solidFill>
-            <a:srgbClr val="111827"/>
+            <a:srgbClr val="FFFFFF"/>
           </a:solidFill>
-          <a:ln w="19050">
+          <a:ln>
             <a:solidFill>
-              <a:srgbClr val="6366F1"/>
+              <a:srgbClr val="E2E8F0"/>
             </a:solidFill>
           </a:ln>
         </p:spPr>
@@ -3351,94 +4085,101 @@
           </a:fontRef>
         </p:style>
         <p:txBody>
-          <a:bodyPr rtlCol="0" anchor="ctr" wrap="square" lIns="182880" tIns="182880" rIns="182880" bIns="182880"/>
-          <a:lstStyle/>
-          <a:p>
-            <a:pPr algn="ctr">
-              <a:spcAft>
-                <a:spcPts val="1200"/>
-              </a:spcAft>
-              <a:defRPr sz="1800" b="1">
-                <a:solidFill>
-                  <a:srgbClr val="10B981"/>
-                </a:solidFill>
-                <a:latin typeface="Trebuchet MS"/>
-              </a:defRPr>
-            </a:pPr>
-            <a:r>
-              <a:t>Key Financial Metrics</a:t>
-            </a:r>
-          </a:p>
-          <a:p>
-            <a:pPr>
-              <a:spcAft>
-                <a:spcPts val="600"/>
-              </a:spcAft>
-              <a:defRPr sz="1300">
-                <a:solidFill>
-                  <a:srgbClr val="F8FAFC"/>
-                </a:solidFill>
-                <a:latin typeface="Calibri"/>
-              </a:defRPr>
-            </a:pPr>
-            <a:r>
-              <a:t>• Total Net Balance: Real-time lifetime remaining balance calculated across all assets.</a:t>
-            </a:r>
-          </a:p>
-          <a:p>
-            <a:pPr>
-              <a:spcAft>
-                <a:spcPts val="600"/>
-              </a:spcAft>
-              <a:defRPr sz="1300">
-                <a:solidFill>
-                  <a:srgbClr val="F8FAFC"/>
-                </a:solidFill>
-                <a:latin typeface="Calibri"/>
-              </a:defRPr>
-            </a:pPr>
-            <a:r>
-              <a:t>• Monthly Income/Expenses: Comparative indicator displaying current monthly cashflows.</a:t>
-            </a:r>
-          </a:p>
-          <a:p>
-            <a:pPr>
-              <a:spcAft>
-                <a:spcPts val="600"/>
-              </a:spcAft>
-              <a:defRPr sz="1300">
-                <a:solidFill>
-                  <a:srgbClr val="F8FAFC"/>
-                </a:solidFill>
-                <a:latin typeface="Calibri"/>
-              </a:defRPr>
-            </a:pPr>
-            <a:r>
-              <a:t>• Savings &amp; Savings Rate: Dynamic savings statistics outlining margins and saving speed.</a:t>
-            </a:r>
-          </a:p>
-        </p:txBody>
-      </p:sp>
-      <p:sp>
-        <p:nvSpPr>
-          <p:cNvPr id="6" name="Rectangle 5"/>
-          <p:cNvSpPr/>
+          <a:bodyPr rtlCol="0" anchor="ctr"/>
+          <a:lstStyle/>
+          <a:p>
+            <a:pPr algn="ctr"/>
+          </a:p>
+        </p:txBody>
+      </p:sp>
+      <p:sp>
+        <p:nvSpPr>
+          <p:cNvPr id="4" name="TextBox 3"/>
+          <p:cNvSpPr txBox="1"/>
           <p:nvPr/>
         </p:nvSpPr>
         <p:spPr>
           <a:xfrm>
-            <a:off x="4389120" y="1645920"/>
-            <a:ext cx="3291840" cy="4389120"/>
+            <a:off x="868680" y="1965960"/>
+            <a:ext cx="3108960" cy="1645920"/>
           </a:xfrm>
           <a:prstGeom prst="rect">
             <a:avLst/>
           </a:prstGeom>
+          <a:noFill/>
+        </p:spPr>
+        <p:txBody>
+          <a:bodyPr wrap="square" lIns="0" tIns="0" rIns="0" bIns="0">
+            <a:spAutoFit/>
+          </a:bodyPr>
+          <a:lstStyle/>
+          <a:p>
+            <a:pPr>
+              <a:spcAft>
+                <a:spcPts val="200"/>
+              </a:spcAft>
+              <a:defRPr sz="1400" b="1">
+                <a:solidFill>
+                  <a:srgbClr val="6366F1"/>
+                </a:solidFill>
+                <a:latin typeface="Outfit"/>
+              </a:defRPr>
+            </a:pPr>
+            <a:r>
+              <a:t>01</a:t>
+            </a:r>
+          </a:p>
+          <a:p>
+            <a:pPr>
+              <a:spcAft>
+                <a:spcPts val="400"/>
+              </a:spcAft>
+              <a:defRPr sz="1400" b="1">
+                <a:solidFill>
+                  <a:srgbClr val="0F172A"/>
+                </a:solidFill>
+                <a:latin typeface="Outfit"/>
+              </a:defRPr>
+            </a:pPr>
+            <a:r>
+              <a:t>Introduction &amp; Overview</a:t>
+            </a:r>
+          </a:p>
+          <a:p>
+            <a:pPr>
+              <a:defRPr sz="1050">
+                <a:solidFill>
+                  <a:srgbClr val="64748B"/>
+                </a:solidFill>
+                <a:latin typeface="Inter"/>
+              </a:defRPr>
+            </a:pPr>
+            <a:r>
+              <a:t>Executive recap of value proposition and business benefits.</a:t>
+            </a:r>
+          </a:p>
+        </p:txBody>
+      </p:sp>
+      <p:sp>
+        <p:nvSpPr>
+          <p:cNvPr id="5" name="Rounded Rectangle 4"/>
+          <p:cNvSpPr/>
+          <p:nvPr/>
+        </p:nvSpPr>
+        <p:spPr>
+          <a:xfrm>
+            <a:off x="4389120" y="1828800"/>
+            <a:ext cx="3383280" cy="1920240"/>
+          </a:xfrm>
+          <a:prstGeom prst="roundRect">
+            <a:avLst/>
+          </a:prstGeom>
           <a:solidFill>
-            <a:srgbClr val="111827"/>
+            <a:srgbClr val="FFFFFF"/>
           </a:solidFill>
-          <a:ln w="19050">
+          <a:ln>
             <a:solidFill>
-              <a:srgbClr val="10B981"/>
+              <a:srgbClr val="E2E8F0"/>
             </a:solidFill>
           </a:ln>
         </p:spPr>
@@ -3457,94 +4198,101 @@
           </a:fontRef>
         </p:style>
         <p:txBody>
-          <a:bodyPr rtlCol="0" anchor="ctr" wrap="square" lIns="182880" tIns="182880" rIns="182880" bIns="182880"/>
-          <a:lstStyle/>
-          <a:p>
-            <a:pPr algn="ctr">
-              <a:spcAft>
-                <a:spcPts val="1200"/>
-              </a:spcAft>
-              <a:defRPr sz="1800" b="1">
-                <a:solidFill>
-                  <a:srgbClr val="10B981"/>
-                </a:solidFill>
-                <a:latin typeface="Trebuchet MS"/>
-              </a:defRPr>
-            </a:pPr>
-            <a:r>
-              <a:t>Financial Health Score</a:t>
-            </a:r>
-          </a:p>
-          <a:p>
-            <a:pPr>
-              <a:spcAft>
-                <a:spcPts val="600"/>
-              </a:spcAft>
-              <a:defRPr sz="1300">
-                <a:solidFill>
-                  <a:srgbClr val="F8FAFC"/>
-                </a:solidFill>
-                <a:latin typeface="Calibri"/>
-              </a:defRPr>
-            </a:pPr>
-            <a:r>
-              <a:t>• Score Range: 0 to 100 points.</a:t>
-            </a:r>
-          </a:p>
-          <a:p>
-            <a:pPr>
-              <a:spcAft>
-                <a:spcPts val="600"/>
-              </a:spcAft>
-              <a:defRPr sz="1300">
-                <a:solidFill>
-                  <a:srgbClr val="F8FAFC"/>
-                </a:solidFill>
-                <a:latin typeface="Calibri"/>
-              </a:defRPr>
-            </a:pPr>
-            <a:r>
-              <a:t>• Positive Components: Awarded points for higher savings rates (+30) and budget safety (+15).</a:t>
-            </a:r>
-          </a:p>
-          <a:p>
-            <a:pPr>
-              <a:spcAft>
-                <a:spcPts val="600"/>
-              </a:spcAft>
-              <a:defRPr sz="1300">
-                <a:solidFill>
-                  <a:srgbClr val="F8FAFC"/>
-                </a:solidFill>
-                <a:latin typeface="Calibri"/>
-              </a:defRPr>
-            </a:pPr>
-            <a:r>
-              <a:t>• Negatives Deductions: Deduct points (-10 per overrun) when category budget safety checks fail.</a:t>
-            </a:r>
-          </a:p>
-        </p:txBody>
-      </p:sp>
-      <p:sp>
-        <p:nvSpPr>
-          <p:cNvPr id="7" name="Rectangle 6"/>
-          <p:cNvSpPr/>
+          <a:bodyPr rtlCol="0" anchor="ctr"/>
+          <a:lstStyle/>
+          <a:p>
+            <a:pPr algn="ctr"/>
+          </a:p>
+        </p:txBody>
+      </p:sp>
+      <p:sp>
+        <p:nvSpPr>
+          <p:cNvPr id="6" name="TextBox 5"/>
+          <p:cNvSpPr txBox="1"/>
           <p:nvPr/>
         </p:nvSpPr>
         <p:spPr>
           <a:xfrm>
-            <a:off x="8046720" y="1645920"/>
-            <a:ext cx="3383280" cy="4389120"/>
+            <a:off x="4526280" y="1965960"/>
+            <a:ext cx="3108960" cy="1645920"/>
           </a:xfrm>
           <a:prstGeom prst="rect">
             <a:avLst/>
           </a:prstGeom>
+          <a:noFill/>
+        </p:spPr>
+        <p:txBody>
+          <a:bodyPr wrap="square" lIns="0" tIns="0" rIns="0" bIns="0">
+            <a:spAutoFit/>
+          </a:bodyPr>
+          <a:lstStyle/>
+          <a:p>
+            <a:pPr>
+              <a:spcAft>
+                <a:spcPts val="200"/>
+              </a:spcAft>
+              <a:defRPr sz="1400" b="1">
+                <a:solidFill>
+                  <a:srgbClr val="6366F1"/>
+                </a:solidFill>
+                <a:latin typeface="Outfit"/>
+              </a:defRPr>
+            </a:pPr>
+            <a:r>
+              <a:t>02</a:t>
+            </a:r>
+          </a:p>
+          <a:p>
+            <a:pPr>
+              <a:spcAft>
+                <a:spcPts val="400"/>
+              </a:spcAft>
+              <a:defRPr sz="1400" b="1">
+                <a:solidFill>
+                  <a:srgbClr val="0F172A"/>
+                </a:solidFill>
+                <a:latin typeface="Outfit"/>
+              </a:defRPr>
+            </a:pPr>
+            <a:r>
+              <a:t>Technology Stack Modules</a:t>
+            </a:r>
+          </a:p>
+          <a:p>
+            <a:pPr>
+              <a:defRPr sz="1050">
+                <a:solidFill>
+                  <a:srgbClr val="64748B"/>
+                </a:solidFill>
+                <a:latin typeface="Inter"/>
+              </a:defRPr>
+            </a:pPr>
+            <a:r>
+              <a:t>Core frameworks, styling components, and backend databases.</a:t>
+            </a:r>
+          </a:p>
+        </p:txBody>
+      </p:sp>
+      <p:sp>
+        <p:nvSpPr>
+          <p:cNvPr id="7" name="Rounded Rectangle 6"/>
+          <p:cNvSpPr/>
+          <p:nvPr/>
+        </p:nvSpPr>
+        <p:spPr>
+          <a:xfrm>
+            <a:off x="8046720" y="1828800"/>
+            <a:ext cx="3383280" cy="1920240"/>
+          </a:xfrm>
+          <a:prstGeom prst="roundRect">
+            <a:avLst/>
+          </a:prstGeom>
           <a:solidFill>
-            <a:srgbClr val="111827"/>
+            <a:srgbClr val="FFFFFF"/>
           </a:solidFill>
-          <a:ln w="19050">
+          <a:ln>
             <a:solidFill>
-              <a:srgbClr val="6366F1"/>
+              <a:srgbClr val="E2E8F0"/>
             </a:solidFill>
           </a:ln>
         </p:spPr>
@@ -3563,110 +4311,23 @@
           </a:fontRef>
         </p:style>
         <p:txBody>
-          <a:bodyPr rtlCol="0" anchor="ctr" wrap="square" lIns="182880" tIns="182880" rIns="182880" bIns="182880"/>
-          <a:lstStyle/>
-          <a:p>
-            <a:pPr algn="ctr">
-              <a:spcAft>
-                <a:spcPts val="1200"/>
-              </a:spcAft>
-              <a:defRPr sz="1800" b="1">
-                <a:solidFill>
-                  <a:srgbClr val="10B981"/>
-                </a:solidFill>
-                <a:latin typeface="Trebuchet MS"/>
-              </a:defRPr>
-            </a:pPr>
-            <a:r>
-              <a:t>UI &amp; Visual Highlights</a:t>
-            </a:r>
-          </a:p>
-          <a:p>
-            <a:pPr>
-              <a:spcAft>
-                <a:spcPts val="600"/>
-              </a:spcAft>
-              <a:defRPr sz="1300">
-                <a:solidFill>
-                  <a:srgbClr val="F8FAFC"/>
-                </a:solidFill>
-                <a:latin typeface="Calibri"/>
-              </a:defRPr>
-            </a:pPr>
-            <a:r>
-              <a:t>• Glassmorphic design: Styled with frosted glass effects and neon border highlights.</a:t>
-            </a:r>
-          </a:p>
-          <a:p>
-            <a:pPr>
-              <a:spcAft>
-                <a:spcPts val="600"/>
-              </a:spcAft>
-              <a:defRPr sz="1300">
-                <a:solidFill>
-                  <a:srgbClr val="F8FAFC"/>
-                </a:solidFill>
-                <a:latin typeface="Calibri"/>
-              </a:defRPr>
-            </a:pPr>
-            <a:r>
-              <a:t>• Widescreen grids: Perfectly aligned cards scaled to fit standard desktop screens.</a:t>
-            </a:r>
-          </a:p>
-          <a:p>
-            <a:pPr>
-              <a:spcAft>
-                <a:spcPts val="600"/>
-              </a:spcAft>
-              <a:defRPr sz="1300">
-                <a:solidFill>
-                  <a:srgbClr val="F8FAFC"/>
-                </a:solidFill>
-                <a:latin typeface="Calibri"/>
-              </a:defRPr>
-            </a:pPr>
-            <a:r>
-              <a:t>• Radial ring progress: Custom animated SVG gauges displaying financial health.</a:t>
-            </a:r>
-          </a:p>
-        </p:txBody>
-      </p:sp>
-    </p:spTree>
-  </p:cSld>
-  <p:clrMapOvr>
-    <a:masterClrMapping/>
-  </p:clrMapOvr>
-</p:sld>
-</file>
-
-<file path=ppt/slides/slide3.xml><?xml version="1.0" encoding="utf-8"?>
-<p:sld xmlns:a="http://schemas.openxmlformats.org/drawingml/2006/main" xmlns:p="http://schemas.openxmlformats.org/presentationml/2006/main" xmlns:r="http://schemas.openxmlformats.org/officeDocument/2006/relationships">
-  <p:cSld>
-    <p:bg>
-      <p:bgPr>
-        <a:solidFill>
-          <a:srgbClr val="090D16"/>
-        </a:solidFill>
-        <a:effectLst/>
-      </p:bgPr>
-    </p:bg>
-    <p:spTree>
-      <p:nvGrpSpPr>
-        <p:cNvPr id="1" name=""/>
-        <p:cNvGrpSpPr/>
-        <p:nvPr/>
-      </p:nvGrpSpPr>
-      <p:grpSpPr/>
-      <p:sp>
-        <p:nvSpPr>
-          <p:cNvPr id="2" name="TextBox 1"/>
+          <a:bodyPr rtlCol="0" anchor="ctr"/>
+          <a:lstStyle/>
+          <a:p>
+            <a:pPr algn="ctr"/>
+          </a:p>
+        </p:txBody>
+      </p:sp>
+      <p:sp>
+        <p:nvSpPr>
+          <p:cNvPr id="8" name="TextBox 7"/>
           <p:cNvSpPr txBox="1"/>
           <p:nvPr/>
         </p:nvSpPr>
         <p:spPr>
           <a:xfrm>
-            <a:off x="731520" y="365760"/>
-            <a:ext cx="10698480" cy="365760"/>
+            <a:off x="8183880" y="1965960"/>
+            <a:ext cx="3108960" cy="1645920"/>
           </a:xfrm>
           <a:prstGeom prst="rect">
             <a:avLst/>
@@ -3674,124 +4335,77 @@
           <a:noFill/>
         </p:spPr>
         <p:txBody>
-          <a:bodyPr wrap="none">
+          <a:bodyPr wrap="square" lIns="0" tIns="0" rIns="0" bIns="0">
             <a:spAutoFit/>
           </a:bodyPr>
           <a:lstStyle/>
           <a:p>
             <a:pPr>
-              <a:defRPr sz="1100" b="1">
+              <a:spcAft>
+                <a:spcPts val="200"/>
+              </a:spcAft>
+              <a:defRPr sz="1400" b="1">
                 <a:solidFill>
                   <a:srgbClr val="6366F1"/>
                 </a:solidFill>
-                <a:latin typeface="Trebuchet MS"/>
-              </a:defRPr>
-            </a:pPr>
-            <a:r>
-              <a:t>EXPENSETRACKER FEATURES</a:t>
-            </a:r>
-          </a:p>
-        </p:txBody>
-      </p:sp>
-      <p:sp>
-        <p:nvSpPr>
-          <p:cNvPr id="3" name="TextBox 2"/>
-          <p:cNvSpPr txBox="1"/>
+                <a:latin typeface="Outfit"/>
+              </a:defRPr>
+            </a:pPr>
+            <a:r>
+              <a:t>03</a:t>
+            </a:r>
+          </a:p>
+          <a:p>
+            <a:pPr>
+              <a:spcAft>
+                <a:spcPts val="400"/>
+              </a:spcAft>
+              <a:defRPr sz="1400" b="1">
+                <a:solidFill>
+                  <a:srgbClr val="0F172A"/>
+                </a:solidFill>
+                <a:latin typeface="Outfit"/>
+              </a:defRPr>
+            </a:pPr>
+            <a:r>
+              <a:t>Personalization Suite</a:t>
+            </a:r>
+          </a:p>
+          <a:p>
+            <a:pPr>
+              <a:defRPr sz="1050">
+                <a:solidFill>
+                  <a:srgbClr val="64748B"/>
+                </a:solidFill>
+                <a:latin typeface="Inter"/>
+              </a:defRPr>
+            </a:pPr>
+            <a:r>
+              <a:t>Dynamic translations, custom swatches, and custom categories.</a:t>
+            </a:r>
+          </a:p>
+        </p:txBody>
+      </p:sp>
+      <p:sp>
+        <p:nvSpPr>
+          <p:cNvPr id="9" name="Rounded Rectangle 8"/>
+          <p:cNvSpPr/>
           <p:nvPr/>
         </p:nvSpPr>
         <p:spPr>
           <a:xfrm>
-            <a:off x="731520" y="640080"/>
-            <a:ext cx="10698480" cy="731520"/>
+            <a:off x="731520" y="4114800"/>
+            <a:ext cx="3383280" cy="1920240"/>
           </a:xfrm>
-          <a:prstGeom prst="rect">
-            <a:avLst/>
-          </a:prstGeom>
-          <a:noFill/>
-        </p:spPr>
-        <p:txBody>
-          <a:bodyPr wrap="none">
-            <a:spAutoFit/>
-          </a:bodyPr>
-          <a:lstStyle/>
-          <a:p>
-            <a:pPr>
-              <a:defRPr sz="2800" b="1">
-                <a:solidFill>
-                  <a:srgbClr val="F8FAFC"/>
-                </a:solidFill>
-                <a:latin typeface="Trebuchet MS"/>
-              </a:defRPr>
-            </a:pPr>
-            <a:r>
-              <a:t>Advanced Transaction Ledger</a:t>
-            </a:r>
-          </a:p>
-        </p:txBody>
-      </p:sp>
-      <p:sp>
-        <p:nvSpPr>
-          <p:cNvPr id="4" name="Rectangle 3"/>
-          <p:cNvSpPr/>
-          <p:nvPr/>
-        </p:nvSpPr>
-        <p:spPr>
-          <a:xfrm>
-            <a:off x="731520" y="1371600"/>
-            <a:ext cx="10698480" cy="36576"/>
-          </a:xfrm>
-          <a:prstGeom prst="rect">
+          <a:prstGeom prst="roundRect">
             <a:avLst/>
           </a:prstGeom>
           <a:solidFill>
-            <a:srgbClr val="10B981"/>
+            <a:srgbClr val="FFFFFF"/>
           </a:solidFill>
           <a:ln>
-            <a:noFill/>
-          </a:ln>
-        </p:spPr>
-        <p:style>
-          <a:lnRef idx="1">
-            <a:schemeClr val="accent1"/>
-          </a:lnRef>
-          <a:fillRef idx="3">
-            <a:schemeClr val="accent1"/>
-          </a:fillRef>
-          <a:effectRef idx="2">
-            <a:schemeClr val="accent1"/>
-          </a:effectRef>
-          <a:fontRef idx="minor">
-            <a:schemeClr val="lt1"/>
-          </a:fontRef>
-        </p:style>
-        <p:txBody>
-          <a:bodyPr rtlCol="0" anchor="ctr"/>
-          <a:lstStyle/>
-          <a:p>
-            <a:pPr algn="ctr"/>
-          </a:p>
-        </p:txBody>
-      </p:sp>
-      <p:sp>
-        <p:nvSpPr>
-          <p:cNvPr id="5" name="Rectangle 4"/>
-          <p:cNvSpPr/>
-          <p:nvPr/>
-        </p:nvSpPr>
-        <p:spPr>
-          <a:xfrm>
-            <a:off x="731520" y="1645920"/>
-            <a:ext cx="5120640" cy="4389120"/>
-          </a:xfrm>
-          <a:prstGeom prst="rect">
-            <a:avLst/>
-          </a:prstGeom>
-          <a:solidFill>
-            <a:srgbClr val="111827"/>
-          </a:solidFill>
-          <a:ln w="19050">
             <a:solidFill>
-              <a:srgbClr val="10B981"/>
+              <a:srgbClr val="E2E8F0"/>
             </a:solidFill>
           </a:ln>
         </p:spPr>
@@ -3810,110 +4424,101 @@
           </a:fontRef>
         </p:style>
         <p:txBody>
-          <a:bodyPr rtlCol="0" anchor="ctr" wrap="square" lIns="182880" tIns="182880" rIns="182880" bIns="182880"/>
-          <a:lstStyle/>
-          <a:p>
-            <a:pPr algn="ctr">
-              <a:spcAft>
-                <a:spcPts val="1200"/>
-              </a:spcAft>
-              <a:defRPr sz="1800" b="1">
-                <a:solidFill>
-                  <a:srgbClr val="10B981"/>
-                </a:solidFill>
-                <a:latin typeface="Trebuchet MS"/>
-              </a:defRPr>
-            </a:pPr>
-            <a:r>
-              <a:t>Transaction Management Engine</a:t>
-            </a:r>
-          </a:p>
-          <a:p>
-            <a:pPr>
-              <a:spcAft>
-                <a:spcPts val="600"/>
-              </a:spcAft>
-              <a:defRPr sz="1300">
-                <a:solidFill>
-                  <a:srgbClr val="F8FAFC"/>
-                </a:solidFill>
-                <a:latin typeface="Calibri"/>
-              </a:defRPr>
-            </a:pPr>
-            <a:r>
-              <a:t>• Dual Class Ledger: Supports registering Cash Inflow (Income) and Cash Outflow (Expense).</a:t>
-            </a:r>
-          </a:p>
-          <a:p>
-            <a:pPr>
-              <a:spcAft>
-                <a:spcPts val="600"/>
-              </a:spcAft>
-              <a:defRPr sz="1300">
-                <a:solidFill>
-                  <a:srgbClr val="F8FAFC"/>
-                </a:solidFill>
-                <a:latin typeface="Calibri"/>
-              </a:defRPr>
-            </a:pPr>
-            <a:r>
-              <a:t>• Custom Category mapping: Auto-integrates standard categories and user customization tags.</a:t>
-            </a:r>
-          </a:p>
-          <a:p>
-            <a:pPr>
-              <a:spcAft>
-                <a:spcPts val="600"/>
-              </a:spcAft>
-              <a:defRPr sz="1300">
-                <a:solidFill>
-                  <a:srgbClr val="F8FAFC"/>
-                </a:solidFill>
-                <a:latin typeface="Calibri"/>
-              </a:defRPr>
-            </a:pPr>
-            <a:r>
-              <a:t>• Optional parameters: Upload physical receipts directly and add custom details strings.</a:t>
-            </a:r>
-          </a:p>
-          <a:p>
-            <a:pPr>
-              <a:spcAft>
-                <a:spcPts val="600"/>
-              </a:spcAft>
-              <a:defRPr sz="1300">
-                <a:solidFill>
-                  <a:srgbClr val="F8FAFC"/>
-                </a:solidFill>
-                <a:latin typeface="Calibri"/>
-              </a:defRPr>
-            </a:pPr>
-            <a:r>
-              <a:t>• Security validation: Prevents negative amount entry, requires inputs, and protects user bounds.</a:t>
-            </a:r>
-          </a:p>
-        </p:txBody>
-      </p:sp>
-      <p:sp>
-        <p:nvSpPr>
-          <p:cNvPr id="6" name="Rectangle 5"/>
-          <p:cNvSpPr/>
+          <a:bodyPr rtlCol="0" anchor="ctr"/>
+          <a:lstStyle/>
+          <a:p>
+            <a:pPr algn="ctr"/>
+          </a:p>
+        </p:txBody>
+      </p:sp>
+      <p:sp>
+        <p:nvSpPr>
+          <p:cNvPr id="10" name="TextBox 9"/>
+          <p:cNvSpPr txBox="1"/>
           <p:nvPr/>
         </p:nvSpPr>
         <p:spPr>
           <a:xfrm>
-            <a:off x="6217920" y="1645920"/>
-            <a:ext cx="5212080" cy="4389120"/>
+            <a:off x="868680" y="4251960"/>
+            <a:ext cx="3108960" cy="1645920"/>
           </a:xfrm>
           <a:prstGeom prst="rect">
             <a:avLst/>
           </a:prstGeom>
+          <a:noFill/>
+        </p:spPr>
+        <p:txBody>
+          <a:bodyPr wrap="square" lIns="0" tIns="0" rIns="0" bIns="0">
+            <a:spAutoFit/>
+          </a:bodyPr>
+          <a:lstStyle/>
+          <a:p>
+            <a:pPr>
+              <a:spcAft>
+                <a:spcPts val="200"/>
+              </a:spcAft>
+              <a:defRPr sz="1400" b="1">
+                <a:solidFill>
+                  <a:srgbClr val="6366F1"/>
+                </a:solidFill>
+                <a:latin typeface="Outfit"/>
+              </a:defRPr>
+            </a:pPr>
+            <a:r>
+              <a:t>04</a:t>
+            </a:r>
+          </a:p>
+          <a:p>
+            <a:pPr>
+              <a:spcAft>
+                <a:spcPts val="400"/>
+              </a:spcAft>
+              <a:defRPr sz="1400" b="1">
+                <a:solidFill>
+                  <a:srgbClr val="0F172A"/>
+                </a:solidFill>
+                <a:latin typeface="Outfit"/>
+              </a:defRPr>
+            </a:pPr>
+            <a:r>
+              <a:t>Ledger &amp; Transaction Audits</a:t>
+            </a:r>
+          </a:p>
+          <a:p>
+            <a:pPr>
+              <a:defRPr sz="1050">
+                <a:solidFill>
+                  <a:srgbClr val="64748B"/>
+                </a:solidFill>
+                <a:latin typeface="Inter"/>
+              </a:defRPr>
+            </a:pPr>
+            <a:r>
+              <a:t>Data entries, receipt uploads, and category ledger views.</a:t>
+            </a:r>
+          </a:p>
+        </p:txBody>
+      </p:sp>
+      <p:sp>
+        <p:nvSpPr>
+          <p:cNvPr id="11" name="Rounded Rectangle 10"/>
+          <p:cNvSpPr/>
+          <p:nvPr/>
+        </p:nvSpPr>
+        <p:spPr>
+          <a:xfrm>
+            <a:off x="4389120" y="4114800"/>
+            <a:ext cx="3383280" cy="1920240"/>
+          </a:xfrm>
+          <a:prstGeom prst="roundRect">
+            <a:avLst/>
+          </a:prstGeom>
           <a:solidFill>
-            <a:srgbClr val="111827"/>
+            <a:srgbClr val="FFFFFF"/>
           </a:solidFill>
-          <a:ln w="19050">
+          <a:ln>
             <a:solidFill>
-              <a:srgbClr val="6366F1"/>
+              <a:srgbClr val="E2E8F0"/>
             </a:solidFill>
           </a:ln>
         </p:spPr>
@@ -3932,126 +4537,23 @@
           </a:fontRef>
         </p:style>
         <p:txBody>
-          <a:bodyPr rtlCol="0" anchor="ctr" wrap="square" lIns="182880" tIns="182880" rIns="182880" bIns="182880"/>
-          <a:lstStyle/>
-          <a:p>
-            <a:pPr algn="ctr">
-              <a:spcAft>
-                <a:spcPts val="1200"/>
-              </a:spcAft>
-              <a:defRPr sz="1800" b="1">
-                <a:solidFill>
-                  <a:srgbClr val="10B981"/>
-                </a:solidFill>
-                <a:latin typeface="Trebuchet MS"/>
-              </a:defRPr>
-            </a:pPr>
-            <a:r>
-              <a:t>Receipt Auditing &amp; Modals</a:t>
-            </a:r>
-          </a:p>
-          <a:p>
-            <a:pPr>
-              <a:spcAft>
-                <a:spcPts val="600"/>
-              </a:spcAft>
-              <a:defRPr sz="1300">
-                <a:solidFill>
-                  <a:srgbClr val="F8FAFC"/>
-                </a:solidFill>
-                <a:latin typeface="Calibri"/>
-              </a:defRPr>
-            </a:pPr>
-            <a:r>
-              <a:t>• Direct Image Uploads: Supports secure storage of png, jpg, jpeg, webp formats.</a:t>
-            </a:r>
-          </a:p>
-          <a:p>
-            <a:pPr>
-              <a:spcAft>
-                <a:spcPts val="600"/>
-              </a:spcAft>
-              <a:defRPr sz="1300">
-                <a:solidFill>
-                  <a:srgbClr val="F8FAFC"/>
-                </a:solidFill>
-                <a:latin typeface="Calibri"/>
-              </a:defRPr>
-            </a:pPr>
-            <a:r>
-              <a:t>• Thumbnails preview: Generates clean list thumbnails inside transaction tables.</a:t>
-            </a:r>
-          </a:p>
-          <a:p>
-            <a:pPr>
-              <a:spcAft>
-                <a:spcPts val="600"/>
-              </a:spcAft>
-              <a:defRPr sz="1300">
-                <a:solidFill>
-                  <a:srgbClr val="F8FAFC"/>
-                </a:solidFill>
-                <a:latin typeface="Calibri"/>
-              </a:defRPr>
-            </a:pPr>
-            <a:r>
-              <a:t>• Modal Lightbox: Opens instant high-resolution receipt views without page navigation.</a:t>
-            </a:r>
-          </a:p>
-          <a:p>
-            <a:pPr>
-              <a:spcAft>
-                <a:spcPts val="600"/>
-              </a:spcAft>
-              <a:defRPr sz="1300">
-                <a:solidFill>
-                  <a:srgbClr val="F8FAFC"/>
-                </a:solidFill>
-                <a:latin typeface="Calibri"/>
-              </a:defRPr>
-            </a:pPr>
-            <a:r>
-              <a:t>• Automatic Cleanups: Deletes linked receipt files from storage if a transaction is removed.</a:t>
-            </a:r>
-          </a:p>
-        </p:txBody>
-      </p:sp>
-    </p:spTree>
-  </p:cSld>
-  <p:clrMapOvr>
-    <a:masterClrMapping/>
-  </p:clrMapOvr>
-</p:sld>
-</file>
-
-<file path=ppt/slides/slide4.xml><?xml version="1.0" encoding="utf-8"?>
-<p:sld xmlns:a="http://schemas.openxmlformats.org/drawingml/2006/main" xmlns:p="http://schemas.openxmlformats.org/presentationml/2006/main" xmlns:r="http://schemas.openxmlformats.org/officeDocument/2006/relationships">
-  <p:cSld>
-    <p:bg>
-      <p:bgPr>
-        <a:solidFill>
-          <a:srgbClr val="090D16"/>
-        </a:solidFill>
-        <a:effectLst/>
-      </p:bgPr>
-    </p:bg>
-    <p:spTree>
-      <p:nvGrpSpPr>
-        <p:cNvPr id="1" name=""/>
-        <p:cNvGrpSpPr/>
-        <p:nvPr/>
-      </p:nvGrpSpPr>
-      <p:grpSpPr/>
-      <p:sp>
-        <p:nvSpPr>
-          <p:cNvPr id="2" name="TextBox 1"/>
+          <a:bodyPr rtlCol="0" anchor="ctr"/>
+          <a:lstStyle/>
+          <a:p>
+            <a:pPr algn="ctr"/>
+          </a:p>
+        </p:txBody>
+      </p:sp>
+      <p:sp>
+        <p:nvSpPr>
+          <p:cNvPr id="12" name="TextBox 11"/>
           <p:cNvSpPr txBox="1"/>
           <p:nvPr/>
         </p:nvSpPr>
         <p:spPr>
           <a:xfrm>
-            <a:off x="731520" y="365760"/>
-            <a:ext cx="10698480" cy="365760"/>
+            <a:off x="4526280" y="4251960"/>
+            <a:ext cx="3108960" cy="1645920"/>
           </a:xfrm>
           <a:prstGeom prst="rect">
             <a:avLst/>
@@ -4059,124 +4561,77 @@
           <a:noFill/>
         </p:spPr>
         <p:txBody>
-          <a:bodyPr wrap="none">
+          <a:bodyPr wrap="square" lIns="0" tIns="0" rIns="0" bIns="0">
             <a:spAutoFit/>
           </a:bodyPr>
           <a:lstStyle/>
           <a:p>
             <a:pPr>
-              <a:defRPr sz="1100" b="1">
+              <a:spcAft>
+                <a:spcPts val="200"/>
+              </a:spcAft>
+              <a:defRPr sz="1400" b="1">
                 <a:solidFill>
                   <a:srgbClr val="6366F1"/>
                 </a:solidFill>
-                <a:latin typeface="Trebuchet MS"/>
-              </a:defRPr>
-            </a:pPr>
-            <a:r>
-              <a:t>EXPENSETRACKER FEATURES</a:t>
-            </a:r>
-          </a:p>
-        </p:txBody>
-      </p:sp>
-      <p:sp>
-        <p:nvSpPr>
-          <p:cNvPr id="3" name="TextBox 2"/>
-          <p:cNvSpPr txBox="1"/>
+                <a:latin typeface="Outfit"/>
+              </a:defRPr>
+            </a:pPr>
+            <a:r>
+              <a:t>05</a:t>
+            </a:r>
+          </a:p>
+          <a:p>
+            <a:pPr>
+              <a:spcAft>
+                <a:spcPts val="400"/>
+              </a:spcAft>
+              <a:defRPr sz="1400" b="1">
+                <a:solidFill>
+                  <a:srgbClr val="0F172A"/>
+                </a:solidFill>
+                <a:latin typeface="Outfit"/>
+              </a:defRPr>
+            </a:pPr>
+            <a:r>
+              <a:t>Budgets &amp; Warnings Engine</a:t>
+            </a:r>
+          </a:p>
+          <a:p>
+            <a:pPr>
+              <a:defRPr sz="1050">
+                <a:solidFill>
+                  <a:srgbClr val="64748B"/>
+                </a:solidFill>
+                <a:latin typeface="Inter"/>
+              </a:defRPr>
+            </a:pPr>
+            <a:r>
+              <a:t>Visual overlays, alert thresholds, and notification controls.</a:t>
+            </a:r>
+          </a:p>
+        </p:txBody>
+      </p:sp>
+      <p:sp>
+        <p:nvSpPr>
+          <p:cNvPr id="13" name="Rounded Rectangle 12"/>
+          <p:cNvSpPr/>
           <p:nvPr/>
         </p:nvSpPr>
         <p:spPr>
           <a:xfrm>
-            <a:off x="731520" y="640080"/>
-            <a:ext cx="10698480" cy="731520"/>
+            <a:off x="8046720" y="4114800"/>
+            <a:ext cx="3383280" cy="1920240"/>
           </a:xfrm>
-          <a:prstGeom prst="rect">
-            <a:avLst/>
-          </a:prstGeom>
-          <a:noFill/>
-        </p:spPr>
-        <p:txBody>
-          <a:bodyPr wrap="none">
-            <a:spAutoFit/>
-          </a:bodyPr>
-          <a:lstStyle/>
-          <a:p>
-            <a:pPr>
-              <a:defRPr sz="2800" b="1">
-                <a:solidFill>
-                  <a:srgbClr val="F8FAFC"/>
-                </a:solidFill>
-                <a:latin typeface="Trebuchet MS"/>
-              </a:defRPr>
-            </a:pPr>
-            <a:r>
-              <a:t>Smart Budget Allocations</a:t>
-            </a:r>
-          </a:p>
-        </p:txBody>
-      </p:sp>
-      <p:sp>
-        <p:nvSpPr>
-          <p:cNvPr id="4" name="Rectangle 3"/>
-          <p:cNvSpPr/>
-          <p:nvPr/>
-        </p:nvSpPr>
-        <p:spPr>
-          <a:xfrm>
-            <a:off x="731520" y="1371600"/>
-            <a:ext cx="10698480" cy="36576"/>
-          </a:xfrm>
-          <a:prstGeom prst="rect">
+          <a:prstGeom prst="roundRect">
             <a:avLst/>
           </a:prstGeom>
           <a:solidFill>
-            <a:srgbClr val="10B981"/>
+            <a:srgbClr val="FFFFFF"/>
           </a:solidFill>
           <a:ln>
-            <a:noFill/>
-          </a:ln>
-        </p:spPr>
-        <p:style>
-          <a:lnRef idx="1">
-            <a:schemeClr val="accent1"/>
-          </a:lnRef>
-          <a:fillRef idx="3">
-            <a:schemeClr val="accent1"/>
-          </a:fillRef>
-          <a:effectRef idx="2">
-            <a:schemeClr val="accent1"/>
-          </a:effectRef>
-          <a:fontRef idx="minor">
-            <a:schemeClr val="lt1"/>
-          </a:fontRef>
-        </p:style>
-        <p:txBody>
-          <a:bodyPr rtlCol="0" anchor="ctr"/>
-          <a:lstStyle/>
-          <a:p>
-            <a:pPr algn="ctr"/>
-          </a:p>
-        </p:txBody>
-      </p:sp>
-      <p:sp>
-        <p:nvSpPr>
-          <p:cNvPr id="5" name="Rectangle 4"/>
-          <p:cNvSpPr/>
-          <p:nvPr/>
-        </p:nvSpPr>
-        <p:spPr>
-          <a:xfrm>
-            <a:off x="731520" y="1645920"/>
-            <a:ext cx="5120640" cy="4389120"/>
-          </a:xfrm>
-          <a:prstGeom prst="rect">
-            <a:avLst/>
-          </a:prstGeom>
-          <a:solidFill>
-            <a:srgbClr val="111827"/>
-          </a:solidFill>
-          <a:ln w="19050">
             <a:solidFill>
-              <a:srgbClr val="6366F1"/>
+              <a:srgbClr val="E2E8F0"/>
             </a:solidFill>
           </a:ln>
         </p:spPr>
@@ -4195,176 +4650,77 @@
           </a:fontRef>
         </p:style>
         <p:txBody>
-          <a:bodyPr rtlCol="0" anchor="ctr" wrap="square" lIns="182880" tIns="182880" rIns="182880" bIns="182880"/>
-          <a:lstStyle/>
-          <a:p>
-            <a:pPr algn="ctr">
-              <a:spcAft>
-                <a:spcPts val="1200"/>
-              </a:spcAft>
-              <a:defRPr sz="1800" b="1">
-                <a:solidFill>
-                  <a:srgbClr val="10B981"/>
-                </a:solidFill>
-                <a:latin typeface="Trebuchet MS"/>
-              </a:defRPr>
-            </a:pPr>
-            <a:r>
-              <a:t>Budget Tracker &amp; Gauges</a:t>
-            </a:r>
-          </a:p>
-          <a:p>
-            <a:pPr>
-              <a:spcAft>
-                <a:spcPts val="600"/>
-              </a:spcAft>
-              <a:defRPr sz="1300">
-                <a:solidFill>
-                  <a:srgbClr val="F8FAFC"/>
-                </a:solidFill>
-                <a:latin typeface="Calibri"/>
-              </a:defRPr>
-            </a:pPr>
-            <a:r>
-              <a:t>• Overall &amp; Category targets: Configure spending limits for custom items or overall monthly caps.</a:t>
-            </a:r>
-          </a:p>
-          <a:p>
-            <a:pPr>
-              <a:spcAft>
-                <a:spcPts val="600"/>
-              </a:spcAft>
-              <a:defRPr sz="1300">
-                <a:solidFill>
-                  <a:srgbClr val="F8FAFC"/>
-                </a:solidFill>
-                <a:latin typeface="Calibri"/>
-              </a:defRPr>
-            </a:pPr>
-            <a:r>
-              <a:t>• Interactive Progress Bars: Colorful indicators mapping budget spent margins (Green: Safe, Yellow: Critical, Red: Breach).</a:t>
-            </a:r>
-          </a:p>
-          <a:p>
-            <a:pPr>
-              <a:spcAft>
-                <a:spcPts val="600"/>
-              </a:spcAft>
-              <a:defRPr sz="1300">
-                <a:solidFill>
-                  <a:srgbClr val="F8FAFC"/>
-                </a:solidFill>
-                <a:latin typeface="Calibri"/>
-              </a:defRPr>
-            </a:pPr>
-            <a:r>
-              <a:t>• Budget warnings: Instantly flashes alerts if a newly added expense breaches budget bounds.</a:t>
-            </a:r>
-          </a:p>
-        </p:txBody>
-      </p:sp>
-      <p:sp>
-        <p:nvSpPr>
-          <p:cNvPr id="6" name="Rectangle 5"/>
-          <p:cNvSpPr/>
+          <a:bodyPr rtlCol="0" anchor="ctr"/>
+          <a:lstStyle/>
+          <a:p>
+            <a:pPr algn="ctr"/>
+          </a:p>
+        </p:txBody>
+      </p:sp>
+      <p:sp>
+        <p:nvSpPr>
+          <p:cNvPr id="14" name="TextBox 13"/>
+          <p:cNvSpPr txBox="1"/>
           <p:nvPr/>
         </p:nvSpPr>
         <p:spPr>
           <a:xfrm>
-            <a:off x="6217920" y="1645920"/>
-            <a:ext cx="5212080" cy="4389120"/>
+            <a:off x="8183880" y="4251960"/>
+            <a:ext cx="3108960" cy="1645920"/>
           </a:xfrm>
           <a:prstGeom prst="rect">
             <a:avLst/>
           </a:prstGeom>
-          <a:solidFill>
-            <a:srgbClr val="111827"/>
-          </a:solidFill>
-          <a:ln w="19050">
-            <a:solidFill>
-              <a:srgbClr val="10B981"/>
-            </a:solidFill>
-          </a:ln>
+          <a:noFill/>
         </p:spPr>
-        <p:style>
-          <a:lnRef idx="1">
-            <a:schemeClr val="accent1"/>
-          </a:lnRef>
-          <a:fillRef idx="3">
-            <a:schemeClr val="accent1"/>
-          </a:fillRef>
-          <a:effectRef idx="2">
-            <a:schemeClr val="accent1"/>
-          </a:effectRef>
-          <a:fontRef idx="minor">
-            <a:schemeClr val="lt1"/>
-          </a:fontRef>
-        </p:style>
-        <p:txBody>
-          <a:bodyPr rtlCol="0" anchor="ctr" wrap="square" lIns="182880" tIns="182880" rIns="182880" bIns="182880"/>
-          <a:lstStyle/>
-          <a:p>
-            <a:pPr algn="ctr">
-              <a:spcAft>
-                <a:spcPts val="1200"/>
-              </a:spcAft>
-              <a:defRPr sz="1800" b="1">
-                <a:solidFill>
-                  <a:srgbClr val="10B981"/>
-                </a:solidFill>
-                <a:latin typeface="Trebuchet MS"/>
-              </a:defRPr>
-            </a:pPr>
-            <a:r>
-              <a:t>Highest Spending Widget</a:t>
-            </a:r>
-          </a:p>
-          <a:p>
-            <a:pPr>
-              <a:spcAft>
-                <a:spcPts val="600"/>
-              </a:spcAft>
-              <a:defRPr sz="1300">
-                <a:solidFill>
-                  <a:srgbClr val="F8FAFC"/>
-                </a:solidFill>
-                <a:latin typeface="Calibri"/>
-              </a:defRPr>
-            </a:pPr>
-            <a:r>
-              <a:t>• Instant Outflow Auditing: Automatically highlights the user's highest spending category.</a:t>
-            </a:r>
-          </a:p>
-          <a:p>
-            <a:pPr>
-              <a:spcAft>
-                <a:spcPts val="600"/>
-              </a:spcAft>
-              <a:defRPr sz="1300">
-                <a:solidFill>
-                  <a:srgbClr val="F8FAFC"/>
-                </a:solidFill>
-                <a:latin typeface="Calibri"/>
-              </a:defRPr>
-            </a:pPr>
-            <a:r>
-              <a:t>• Accrued calculations: Tracks category limits and totals cumulative spent values dynamically.</a:t>
-            </a:r>
-          </a:p>
-          <a:p>
-            <a:pPr>
-              <a:spcAft>
-                <a:spcPts val="600"/>
-              </a:spcAft>
-              <a:defRPr sz="1300">
-                <a:solidFill>
-                  <a:srgbClr val="F8FAFC"/>
-                </a:solidFill>
-                <a:latin typeface="Calibri"/>
-              </a:defRPr>
-            </a:pPr>
-            <a:r>
-              <a:t>• Quick link paths: Dynamic links to view detailed historical category graphs on the Reports page.</a:t>
+        <p:txBody>
+          <a:bodyPr wrap="square" lIns="0" tIns="0" rIns="0" bIns="0">
+            <a:spAutoFit/>
+          </a:bodyPr>
+          <a:lstStyle/>
+          <a:p>
+            <a:pPr>
+              <a:spcAft>
+                <a:spcPts val="200"/>
+              </a:spcAft>
+              <a:defRPr sz="1400" b="1">
+                <a:solidFill>
+                  <a:srgbClr val="6366F1"/>
+                </a:solidFill>
+                <a:latin typeface="Outfit"/>
+              </a:defRPr>
+            </a:pPr>
+            <a:r>
+              <a:t>06</a:t>
+            </a:r>
+          </a:p>
+          <a:p>
+            <a:pPr>
+              <a:spcAft>
+                <a:spcPts val="400"/>
+              </a:spcAft>
+              <a:defRPr sz="1400" b="1">
+                <a:solidFill>
+                  <a:srgbClr val="0F172A"/>
+                </a:solidFill>
+                <a:latin typeface="Outfit"/>
+              </a:defRPr>
+            </a:pPr>
+            <a:r>
+              <a:t>Reporting &amp; Exports Engine</a:t>
+            </a:r>
+          </a:p>
+          <a:p>
+            <a:pPr>
+              <a:defRPr sz="1050">
+                <a:solidFill>
+                  <a:srgbClr val="64748B"/>
+                </a:solidFill>
+                <a:latin typeface="Inter"/>
+              </a:defRPr>
+            </a:pPr>
+            <a:r>
+              <a:t>Double-quoted PDF, CSV, and PPTX monthly statements.</a:t>
             </a:r>
           </a:p>
         </p:txBody>
@@ -4383,7 +4739,7 @@
     <p:bg>
       <p:bgPr>
         <a:solidFill>
-          <a:srgbClr val="090D16"/>
+          <a:srgbClr val="0F172A"/>
         </a:solidFill>
         <a:effectLst/>
       </p:bgPr>
@@ -4403,8 +4759,8 @@
         </p:nvSpPr>
         <p:spPr>
           <a:xfrm>
-            <a:off x="731520" y="365760"/>
-            <a:ext cx="10698480" cy="365760"/>
+            <a:off x="731520" y="457200"/>
+            <a:ext cx="10698480" cy="1097280"/>
           </a:xfrm>
           <a:prstGeom prst="rect">
             <a:avLst/>
@@ -4412,21 +4768,37 @@
           <a:noFill/>
         </p:spPr>
         <p:txBody>
-          <a:bodyPr wrap="none">
+          <a:bodyPr wrap="square" lIns="0" tIns="0" rIns="0" bIns="0">
             <a:spAutoFit/>
           </a:bodyPr>
           <a:lstStyle/>
           <a:p>
             <a:pPr>
-              <a:defRPr sz="1100" b="1">
-                <a:solidFill>
-                  <a:srgbClr val="6366F1"/>
-                </a:solidFill>
-                <a:latin typeface="Trebuchet MS"/>
-              </a:defRPr>
-            </a:pPr>
-            <a:r>
-              <a:t>EXPENSETRACKER FEATURES</a:t>
+              <a:spcAft>
+                <a:spcPts val="400"/>
+              </a:spcAft>
+              <a:defRPr sz="1000" b="1">
+                <a:solidFill>
+                  <a:srgbClr val="10B981"/>
+                </a:solidFill>
+                <a:latin typeface="Outfit"/>
+              </a:defRPr>
+            </a:pPr>
+            <a:r>
+              <a:t>04. USER CUSTOMIZATIONS</a:t>
+            </a:r>
+          </a:p>
+          <a:p>
+            <a:pPr>
+              <a:defRPr sz="2800" b="1">
+                <a:solidFill>
+                  <a:srgbClr val="F8FAFC"/>
+                </a:solidFill>
+                <a:latin typeface="Outfit"/>
+              </a:defRPr>
+            </a:pPr>
+            <a:r>
+              <a:t>Granular Personalization Suite</a:t>
             </a:r>
           </a:p>
         </p:txBody>
@@ -4439,8 +4811,8 @@
         </p:nvSpPr>
         <p:spPr>
           <a:xfrm>
-            <a:off x="731520" y="640080"/>
-            <a:ext cx="10698480" cy="731520"/>
+            <a:off x="731520" y="1828800"/>
+            <a:ext cx="10698480" cy="4114800"/>
           </a:xfrm>
           <a:prstGeom prst="rect">
             <a:avLst/>
@@ -4448,276 +4820,152 @@
           <a:noFill/>
         </p:spPr>
         <p:txBody>
-          <a:bodyPr wrap="none">
+          <a:bodyPr wrap="square">
             <a:spAutoFit/>
           </a:bodyPr>
           <a:lstStyle/>
           <a:p>
             <a:pPr>
-              <a:defRPr sz="2800" b="1">
+              <a:spcAft>
+                <a:spcPts val="1600"/>
+              </a:spcAft>
+              <a:defRPr sz="1400">
                 <a:solidFill>
                   <a:srgbClr val="F8FAFC"/>
                 </a:solidFill>
-                <a:latin typeface="Trebuchet MS"/>
-              </a:defRPr>
-            </a:pPr>
-            <a:r>
-              <a:t>Invoice &amp; Upcoming Bills Center</a:t>
-            </a:r>
-          </a:p>
-        </p:txBody>
-      </p:sp>
-      <p:sp>
-        <p:nvSpPr>
-          <p:cNvPr id="4" name="Rectangle 3"/>
-          <p:cNvSpPr/>
-          <p:nvPr/>
-        </p:nvSpPr>
-        <p:spPr>
-          <a:xfrm>
-            <a:off x="731520" y="1371600"/>
-            <a:ext cx="10698480" cy="36576"/>
-          </a:xfrm>
-          <a:prstGeom prst="rect">
-            <a:avLst/>
-          </a:prstGeom>
-          <a:solidFill>
-            <a:srgbClr val="10B981"/>
-          </a:solidFill>
-          <a:ln>
-            <a:noFill/>
-          </a:ln>
-        </p:spPr>
-        <p:style>
-          <a:lnRef idx="1">
-            <a:schemeClr val="accent1"/>
-          </a:lnRef>
-          <a:fillRef idx="3">
-            <a:schemeClr val="accent1"/>
-          </a:fillRef>
-          <a:effectRef idx="2">
-            <a:schemeClr val="accent1"/>
-          </a:effectRef>
-          <a:fontRef idx="minor">
-            <a:schemeClr val="lt1"/>
-          </a:fontRef>
-        </p:style>
-        <p:txBody>
-          <a:bodyPr rtlCol="0" anchor="ctr"/>
-          <a:lstStyle/>
-          <a:p>
-            <a:pPr algn="ctr"/>
-          </a:p>
-        </p:txBody>
-      </p:sp>
-      <p:sp>
-        <p:nvSpPr>
-          <p:cNvPr id="5" name="Rectangle 4"/>
-          <p:cNvSpPr/>
-          <p:nvPr/>
-        </p:nvSpPr>
-        <p:spPr>
-          <a:xfrm>
-            <a:off x="731520" y="1645920"/>
-            <a:ext cx="5120640" cy="4389120"/>
-          </a:xfrm>
-          <a:prstGeom prst="rect">
-            <a:avLst/>
-          </a:prstGeom>
-          <a:solidFill>
-            <a:srgbClr val="111827"/>
-          </a:solidFill>
-          <a:ln w="19050">
-            <a:solidFill>
-              <a:srgbClr val="10B981"/>
-            </a:solidFill>
-          </a:ln>
-        </p:spPr>
-        <p:style>
-          <a:lnRef idx="1">
-            <a:schemeClr val="accent1"/>
-          </a:lnRef>
-          <a:fillRef idx="3">
-            <a:schemeClr val="accent1"/>
-          </a:fillRef>
-          <a:effectRef idx="2">
-            <a:schemeClr val="accent1"/>
-          </a:effectRef>
-          <a:fontRef idx="minor">
-            <a:schemeClr val="lt1"/>
-          </a:fontRef>
-        </p:style>
-        <p:txBody>
-          <a:bodyPr rtlCol="0" anchor="ctr" wrap="square" lIns="182880" tIns="182880" rIns="182880" bIns="182880"/>
-          <a:lstStyle/>
-          <a:p>
-            <a:pPr algn="ctr">
+                <a:latin typeface="Inter"/>
+              </a:defRPr>
+            </a:pPr>
+            <a:r>
+              <a:t>ExpenseTracker provides a personalized interface where every user configuration updates the visual layout without modifying static resource files:</a:t>
+            </a:r>
+          </a:p>
+          <a:p>
+            <a:pPr>
+              <a:spcAft>
+                <a:spcPts val="200"/>
+              </a:spcAft>
+              <a:defRPr sz="1300" b="1">
+                <a:solidFill>
+                  <a:srgbClr val="10B981"/>
+                </a:solidFill>
+                <a:latin typeface="Outfit"/>
+              </a:defRPr>
+            </a:pPr>
+            <a:r>
+              <a:t>✔  Multi-Currency Support: </a:t>
+            </a:r>
+          </a:p>
+          <a:p>
+            <a:pPr>
               <a:spcAft>
                 <a:spcPts val="1200"/>
               </a:spcAft>
-              <a:defRPr sz="1800" b="1">
+              <a:defRPr sz="1200">
+                <a:solidFill>
+                  <a:srgbClr val="94A3B8"/>
+                </a:solidFill>
+                <a:latin typeface="Inter"/>
+              </a:defRPr>
+            </a:pPr>
+            <a:r>
+              <a:t>Select between Rupees (₹), Dollar ($), Euro (€), or Pound (£). All figures dynamically update on cards, ledgers, and export logs.</a:t>
+            </a:r>
+          </a:p>
+          <a:p>
+            <a:pPr>
+              <a:spcAft>
+                <a:spcPts val="200"/>
+              </a:spcAft>
+              <a:defRPr sz="1300" b="1">
                 <a:solidFill>
                   <a:srgbClr val="10B981"/>
                 </a:solidFill>
-                <a:latin typeface="Trebuchet MS"/>
-              </a:defRPr>
-            </a:pPr>
-            <a:r>
-              <a:t>Registration &amp; Due-date Center</a:t>
-            </a:r>
-          </a:p>
-          <a:p>
-            <a:pPr>
-              <a:spcAft>
-                <a:spcPts val="600"/>
-              </a:spcAft>
-              <a:defRPr sz="1300">
-                <a:solidFill>
-                  <a:srgbClr val="F8FAFC"/>
-                </a:solidFill>
-                <a:latin typeface="Calibri"/>
-              </a:defRPr>
-            </a:pPr>
-            <a:r>
-              <a:t>• Register Bills: Add upcoming utilities, credit cards, or bills with amounts, categories, and deadlines.</a:t>
-            </a:r>
-          </a:p>
-          <a:p>
-            <a:pPr>
-              <a:spcAft>
-                <a:spcPts val="600"/>
-              </a:spcAft>
-              <a:defRPr sz="1300">
-                <a:solidFill>
-                  <a:srgbClr val="F8FAFC"/>
-                </a:solidFill>
-                <a:latin typeface="Calibri"/>
-              </a:defRPr>
-            </a:pPr>
-            <a:r>
-              <a:t>• Due Date Ordering: Lists outstanding bills ordered chronologically to keep deadlines visible.</a:t>
-            </a:r>
-          </a:p>
-          <a:p>
-            <a:pPr>
-              <a:spcAft>
-                <a:spcPts val="600"/>
-              </a:spcAft>
-              <a:defRPr sz="1300">
-                <a:solidFill>
-                  <a:srgbClr val="F8FAFC"/>
-                </a:solidFill>
-                <a:latin typeface="Calibri"/>
-              </a:defRPr>
-            </a:pPr>
-            <a:r>
-              <a:t>• Auto-fill dates: Automatically populates inputs with current date for quick logging.</a:t>
-            </a:r>
-          </a:p>
-        </p:txBody>
-      </p:sp>
-      <p:sp>
-        <p:nvSpPr>
-          <p:cNvPr id="6" name="Rectangle 5"/>
-          <p:cNvSpPr/>
-          <p:nvPr/>
-        </p:nvSpPr>
-        <p:spPr>
-          <a:xfrm>
-            <a:off x="6217920" y="1645920"/>
-            <a:ext cx="5212080" cy="4389120"/>
-          </a:xfrm>
-          <a:prstGeom prst="rect">
-            <a:avLst/>
-          </a:prstGeom>
-          <a:solidFill>
-            <a:srgbClr val="111827"/>
-          </a:solidFill>
-          <a:ln w="19050">
-            <a:solidFill>
-              <a:srgbClr val="6366F1"/>
-            </a:solidFill>
-          </a:ln>
-        </p:spPr>
-        <p:style>
-          <a:lnRef idx="1">
-            <a:schemeClr val="accent1"/>
-          </a:lnRef>
-          <a:fillRef idx="3">
-            <a:schemeClr val="accent1"/>
-          </a:fillRef>
-          <a:effectRef idx="2">
-            <a:schemeClr val="accent1"/>
-          </a:effectRef>
-          <a:fontRef idx="minor">
-            <a:schemeClr val="lt1"/>
-          </a:fontRef>
-        </p:style>
-        <p:txBody>
-          <a:bodyPr rtlCol="0" anchor="ctr" wrap="square" lIns="182880" tIns="182880" rIns="182880" bIns="182880"/>
-          <a:lstStyle/>
-          <a:p>
-            <a:pPr algn="ctr">
+                <a:latin typeface="Outfit"/>
+              </a:defRPr>
+            </a:pPr>
+            <a:r>
+              <a:t>✔  Dynamic Localization: </a:t>
+            </a:r>
+          </a:p>
+          <a:p>
+            <a:pPr>
               <a:spcAft>
                 <a:spcPts val="1200"/>
               </a:spcAft>
-              <a:defRPr sz="1800" b="1">
+              <a:defRPr sz="1200">
+                <a:solidFill>
+                  <a:srgbClr val="94A3B8"/>
+                </a:solidFill>
+                <a:latin typeface="Inter"/>
+              </a:defRPr>
+            </a:pPr>
+            <a:r>
+              <a:t>Select between English, Español, and Hindi. Jinja translations automatically localize the titles, headers, labels, and helper texts.</a:t>
+            </a:r>
+          </a:p>
+          <a:p>
+            <a:pPr>
+              <a:spcAft>
+                <a:spcPts val="200"/>
+              </a:spcAft>
+              <a:defRPr sz="1300" b="1">
                 <a:solidFill>
                   <a:srgbClr val="10B981"/>
                 </a:solidFill>
-                <a:latin typeface="Trebuchet MS"/>
-              </a:defRPr>
-            </a:pPr>
-            <a:r>
-              <a:t>One-click Pay Trigger</a:t>
-            </a:r>
-          </a:p>
-          <a:p>
-            <a:pPr>
-              <a:spcAft>
-                <a:spcPts val="600"/>
-              </a:spcAft>
-              <a:defRPr sz="1300">
-                <a:solidFill>
-                  <a:srgbClr val="F8FAFC"/>
-                </a:solidFill>
-                <a:latin typeface="Calibri"/>
-              </a:defRPr>
-            </a:pPr>
-            <a:r>
-              <a:t>• Payment integration: Pay bills with a single click from the dashboard panel.</a:t>
-            </a:r>
-          </a:p>
-          <a:p>
-            <a:pPr>
-              <a:spcAft>
-                <a:spcPts val="600"/>
-              </a:spcAft>
-              <a:defRPr sz="1300">
-                <a:solidFill>
-                  <a:srgbClr val="F8FAFC"/>
-                </a:solidFill>
-                <a:latin typeface="Calibri"/>
-              </a:defRPr>
-            </a:pPr>
-            <a:r>
-              <a:t>• Double-Entry Logger: Automatically logs paid bills as transaction expenses under the correct category.</a:t>
-            </a:r>
-          </a:p>
-          <a:p>
-            <a:pPr>
-              <a:spcAft>
-                <a:spcPts val="600"/>
-              </a:spcAft>
-              <a:defRPr sz="1300">
-                <a:solidFill>
-                  <a:srgbClr val="F8FAFC"/>
-                </a:solidFill>
-                <a:latin typeface="Calibri"/>
-              </a:defRPr>
-            </a:pPr>
-            <a:r>
-              <a:t>• Instant updates: Updates dashboard balance metrics and marks invoice list items paid.</a:t>
+                <a:latin typeface="Outfit"/>
+              </a:defRPr>
+            </a:pPr>
+            <a:r>
+              <a:t>✔  Custom Categories Manager: </a:t>
+            </a:r>
+          </a:p>
+          <a:p>
+            <a:pPr>
+              <a:spcAft>
+                <a:spcPts val="1200"/>
+              </a:spcAft>
+              <a:defRPr sz="1200">
+                <a:solidFill>
+                  <a:srgbClr val="94A3B8"/>
+                </a:solidFill>
+                <a:latin typeface="Inter"/>
+              </a:defRPr>
+            </a:pPr>
+            <a:r>
+              <a:t>Create, list, and delete user-defined categories. Custom tags automatically merge with defaults for transaction entries and filters.</a:t>
+            </a:r>
+          </a:p>
+          <a:p>
+            <a:pPr>
+              <a:spcAft>
+                <a:spcPts val="200"/>
+              </a:spcAft>
+              <a:defRPr sz="1300" b="1">
+                <a:solidFill>
+                  <a:srgbClr val="10B981"/>
+                </a:solidFill>
+                <a:latin typeface="Outfit"/>
+              </a:defRPr>
+            </a:pPr>
+            <a:r>
+              <a:t>✔  Accent Customization: </a:t>
+            </a:r>
+          </a:p>
+          <a:p>
+            <a:pPr>
+              <a:spcAft>
+                <a:spcPts val="1200"/>
+              </a:spcAft>
+              <a:defRPr sz="1200">
+                <a:solidFill>
+                  <a:srgbClr val="94A3B8"/>
+                </a:solidFill>
+                <a:latin typeface="Inter"/>
+              </a:defRPr>
+            </a:pPr>
+            <a:r>
+              <a:t>Choose Indigo, Emerald, Rose, Amber, or Blue themes. Swatches update colors, buttons, and navigation bar gradients.</a:t>
             </a:r>
           </a:p>
         </p:txBody>
@@ -4736,7 +4984,7 @@
     <p:bg>
       <p:bgPr>
         <a:solidFill>
-          <a:srgbClr val="090D16"/>
+          <a:srgbClr val="F8FAFC"/>
         </a:solidFill>
         <a:effectLst/>
       </p:bgPr>
@@ -4756,8 +5004,8 @@
         </p:nvSpPr>
         <p:spPr>
           <a:xfrm>
-            <a:off x="731520" y="365760"/>
-            <a:ext cx="10698480" cy="365760"/>
+            <a:off x="731520" y="457200"/>
+            <a:ext cx="10698480" cy="1097280"/>
           </a:xfrm>
           <a:prstGeom prst="rect">
             <a:avLst/>
@@ -4765,21 +5013,37 @@
           <a:noFill/>
         </p:spPr>
         <p:txBody>
-          <a:bodyPr wrap="none">
+          <a:bodyPr wrap="square" lIns="0" tIns="0" rIns="0" bIns="0">
             <a:spAutoFit/>
           </a:bodyPr>
           <a:lstStyle/>
           <a:p>
             <a:pPr>
-              <a:defRPr sz="1100" b="1">
+              <a:spcAft>
+                <a:spcPts val="400"/>
+              </a:spcAft>
+              <a:defRPr sz="1000" b="1">
                 <a:solidFill>
                   <a:srgbClr val="6366F1"/>
                 </a:solidFill>
-                <a:latin typeface="Trebuchet MS"/>
-              </a:defRPr>
-            </a:pPr>
-            <a:r>
-              <a:t>EXPENSETRACKER FEATURES</a:t>
+                <a:latin typeface="Outfit"/>
+              </a:defRPr>
+            </a:pPr>
+            <a:r>
+              <a:t>05. CORE ACCOUNTING</a:t>
+            </a:r>
+          </a:p>
+          <a:p>
+            <a:pPr>
+              <a:defRPr sz="2800" b="1">
+                <a:solidFill>
+                  <a:srgbClr val="0F172A"/>
+                </a:solidFill>
+                <a:latin typeface="Outfit"/>
+              </a:defRPr>
+            </a:pPr>
+            <a:r>
+              <a:t>Ledger &amp; Transaction Auditing</a:t>
             </a:r>
           </a:p>
         </p:txBody>
@@ -4792,8 +5056,8 @@
         </p:nvSpPr>
         <p:spPr>
           <a:xfrm>
-            <a:off x="731520" y="640080"/>
-            <a:ext cx="10698480" cy="731520"/>
+            <a:off x="731520" y="1828800"/>
+            <a:ext cx="10698480" cy="4114800"/>
           </a:xfrm>
           <a:prstGeom prst="rect">
             <a:avLst/>
@@ -4801,334 +5065,88 @@
           <a:noFill/>
         </p:spPr>
         <p:txBody>
-          <a:bodyPr wrap="none">
+          <a:bodyPr wrap="square">
             <a:spAutoFit/>
           </a:bodyPr>
           <a:lstStyle/>
           <a:p>
             <a:pPr>
-              <a:defRPr sz="2800" b="1">
-                <a:solidFill>
-                  <a:srgbClr val="F8FAFC"/>
-                </a:solidFill>
-                <a:latin typeface="Trebuchet MS"/>
-              </a:defRPr>
-            </a:pPr>
-            <a:r>
-              <a:t>Personalization &amp; UI Customizations</a:t>
-            </a:r>
-          </a:p>
-        </p:txBody>
-      </p:sp>
-      <p:sp>
-        <p:nvSpPr>
-          <p:cNvPr id="4" name="Rectangle 3"/>
-          <p:cNvSpPr/>
-          <p:nvPr/>
-        </p:nvSpPr>
-        <p:spPr>
-          <a:xfrm>
-            <a:off x="731520" y="1371600"/>
-            <a:ext cx="10698480" cy="36576"/>
-          </a:xfrm>
-          <a:prstGeom prst="rect">
-            <a:avLst/>
-          </a:prstGeom>
-          <a:solidFill>
-            <a:srgbClr val="10B981"/>
-          </a:solidFill>
-          <a:ln>
-            <a:noFill/>
-          </a:ln>
-        </p:spPr>
-        <p:style>
-          <a:lnRef idx="1">
-            <a:schemeClr val="accent1"/>
-          </a:lnRef>
-          <a:fillRef idx="3">
-            <a:schemeClr val="accent1"/>
-          </a:fillRef>
-          <a:effectRef idx="2">
-            <a:schemeClr val="accent1"/>
-          </a:effectRef>
-          <a:fontRef idx="minor">
-            <a:schemeClr val="lt1"/>
-          </a:fontRef>
-        </p:style>
-        <p:txBody>
-          <a:bodyPr rtlCol="0" anchor="ctr"/>
-          <a:lstStyle/>
-          <a:p>
-            <a:pPr algn="ctr"/>
-          </a:p>
-        </p:txBody>
-      </p:sp>
-      <p:sp>
-        <p:nvSpPr>
-          <p:cNvPr id="5" name="Rectangle 4"/>
-          <p:cNvSpPr/>
-          <p:nvPr/>
-        </p:nvSpPr>
-        <p:spPr>
-          <a:xfrm>
-            <a:off x="731520" y="1645920"/>
-            <a:ext cx="3291840" cy="4389120"/>
-          </a:xfrm>
-          <a:prstGeom prst="rect">
-            <a:avLst/>
-          </a:prstGeom>
-          <a:solidFill>
-            <a:srgbClr val="111827"/>
-          </a:solidFill>
-          <a:ln w="19050">
-            <a:solidFill>
-              <a:srgbClr val="6366F1"/>
-            </a:solidFill>
-          </a:ln>
-        </p:spPr>
-        <p:style>
-          <a:lnRef idx="1">
-            <a:schemeClr val="accent1"/>
-          </a:lnRef>
-          <a:fillRef idx="3">
-            <a:schemeClr val="accent1"/>
-          </a:fillRef>
-          <a:effectRef idx="2">
-            <a:schemeClr val="accent1"/>
-          </a:effectRef>
-          <a:fontRef idx="minor">
-            <a:schemeClr val="lt1"/>
-          </a:fontRef>
-        </p:style>
-        <p:txBody>
-          <a:bodyPr rtlCol="0" anchor="ctr" wrap="square" lIns="182880" tIns="182880" rIns="182880" bIns="182880"/>
-          <a:lstStyle/>
-          <a:p>
-            <a:pPr algn="ctr">
-              <a:spcAft>
-                <a:spcPts val="1200"/>
-              </a:spcAft>
-              <a:defRPr sz="1800" b="1">
-                <a:solidFill>
-                  <a:srgbClr val="10B981"/>
-                </a:solidFill>
-                <a:latin typeface="Trebuchet MS"/>
-              </a:defRPr>
-            </a:pPr>
-            <a:r>
-              <a:t>Multi-Language &amp; Currency</a:t>
-            </a:r>
-          </a:p>
-          <a:p>
-            <a:pPr>
-              <a:spcAft>
-                <a:spcPts val="600"/>
+              <a:spcAft>
+                <a:spcPts val="1600"/>
+              </a:spcAft>
+              <a:defRPr sz="1400">
+                <a:solidFill>
+                  <a:srgbClr val="0F172A"/>
+                </a:solidFill>
+                <a:latin typeface="Inter"/>
+              </a:defRPr>
+            </a:pPr>
+            <a:r>
+              <a:t>At the core of the platform is an auditing ledger. It allows users to track their finances with metadata details:</a:t>
+            </a:r>
+          </a:p>
+          <a:p>
+            <a:pPr>
+              <a:spcAft>
+                <a:spcPts val="1000"/>
               </a:spcAft>
               <a:defRPr sz="1300">
                 <a:solidFill>
-                  <a:srgbClr val="F8FAFC"/>
-                </a:solidFill>
-                <a:latin typeface="Calibri"/>
-              </a:defRPr>
-            </a:pPr>
-            <a:r>
-              <a:t>• Currencies list: Supports ₹ (Rupees), $ (Dollars), € (Euros), and £ (Pounds). Updates all UI values dynamically.</a:t>
-            </a:r>
-          </a:p>
-          <a:p>
-            <a:pPr>
-              <a:spcAft>
-                <a:spcPts val="600"/>
+                  <a:srgbClr val="64748B"/>
+                </a:solidFill>
+                <a:latin typeface="Inter"/>
+              </a:defRPr>
+            </a:pPr>
+            <a:r>
+              <a:t>▪  Dual Entries: Separate routing controls for income flows and expense records.</a:t>
+            </a:r>
+          </a:p>
+          <a:p>
+            <a:pPr>
+              <a:spcAft>
+                <a:spcPts val="1000"/>
               </a:spcAft>
               <a:defRPr sz="1300">
                 <a:solidFill>
-                  <a:srgbClr val="F8FAFC"/>
-                </a:solidFill>
-                <a:latin typeface="Calibri"/>
-              </a:defRPr>
-            </a:pPr>
-            <a:r>
-              <a:t>• Language translations: Supports English, Spanish, and Hindi translation mappings for headings and inputs.</a:t>
-            </a:r>
-          </a:p>
-        </p:txBody>
-      </p:sp>
-      <p:sp>
-        <p:nvSpPr>
-          <p:cNvPr id="6" name="Rectangle 5"/>
-          <p:cNvSpPr/>
-          <p:nvPr/>
-        </p:nvSpPr>
-        <p:spPr>
-          <a:xfrm>
-            <a:off x="4389120" y="1645920"/>
-            <a:ext cx="3291840" cy="4389120"/>
-          </a:xfrm>
-          <a:prstGeom prst="rect">
-            <a:avLst/>
-          </a:prstGeom>
-          <a:solidFill>
-            <a:srgbClr val="111827"/>
-          </a:solidFill>
-          <a:ln w="19050">
-            <a:solidFill>
-              <a:srgbClr val="10B981"/>
-            </a:solidFill>
-          </a:ln>
-        </p:spPr>
-        <p:style>
-          <a:lnRef idx="1">
-            <a:schemeClr val="accent1"/>
-          </a:lnRef>
-          <a:fillRef idx="3">
-            <a:schemeClr val="accent1"/>
-          </a:fillRef>
-          <a:effectRef idx="2">
-            <a:schemeClr val="accent1"/>
-          </a:effectRef>
-          <a:fontRef idx="minor">
-            <a:schemeClr val="lt1"/>
-          </a:fontRef>
-        </p:style>
-        <p:txBody>
-          <a:bodyPr rtlCol="0" anchor="ctr" wrap="square" lIns="182880" tIns="182880" rIns="182880" bIns="182880"/>
-          <a:lstStyle/>
-          <a:p>
-            <a:pPr algn="ctr">
-              <a:spcAft>
-                <a:spcPts val="1200"/>
-              </a:spcAft>
-              <a:defRPr sz="1800" b="1">
-                <a:solidFill>
-                  <a:srgbClr val="10B981"/>
-                </a:solidFill>
-                <a:latin typeface="Trebuchet MS"/>
-              </a:defRPr>
-            </a:pPr>
-            <a:r>
-              <a:t>Dynamic Theme Accents</a:t>
-            </a:r>
-          </a:p>
-          <a:p>
-            <a:pPr>
-              <a:spcAft>
-                <a:spcPts val="600"/>
+                  <a:srgbClr val="64748B"/>
+                </a:solidFill>
+                <a:latin typeface="Inter"/>
+              </a:defRPr>
+            </a:pPr>
+            <a:r>
+              <a:t>▪  Image Receipts Attachment: Secure local directory file upload (UUID prefixed) to store physical audit evidence.</a:t>
+            </a:r>
+          </a:p>
+          <a:p>
+            <a:pPr>
+              <a:spcAft>
+                <a:spcPts val="1000"/>
               </a:spcAft>
               <a:defRPr sz="1300">
                 <a:solidFill>
-                  <a:srgbClr val="F8FAFC"/>
-                </a:solidFill>
-                <a:latin typeface="Calibri"/>
-              </a:defRPr>
-            </a:pPr>
-            <a:r>
-              <a:t>• Swatches selection: Switch accents to Royal Indigo, Emerald Green, Rose Pink, Amber Yellow, or Ocean Blue.</a:t>
-            </a:r>
-          </a:p>
-          <a:p>
-            <a:pPr>
-              <a:spcAft>
-                <a:spcPts val="600"/>
+                  <a:srgbClr val="64748B"/>
+                </a:solidFill>
+                <a:latin typeface="Inter"/>
+              </a:defRPr>
+            </a:pPr>
+            <a:r>
+              <a:t>▪  Audited Fields: Log exact transactional timestamps, category classifications, and detailed text notes.</a:t>
+            </a:r>
+          </a:p>
+          <a:p>
+            <a:pPr>
+              <a:spcAft>
+                <a:spcPts val="1000"/>
               </a:spcAft>
               <a:defRPr sz="1300">
                 <a:solidFill>
-                  <a:srgbClr val="F8FAFC"/>
-                </a:solidFill>
-                <a:latin typeface="Calibri"/>
-              </a:defRPr>
-            </a:pPr>
-            <a:r>
-              <a:t>• Variables override: Overrides CSS styles dynamically, updating primary colors and button gradients.</a:t>
-            </a:r>
-          </a:p>
-        </p:txBody>
-      </p:sp>
-      <p:sp>
-        <p:nvSpPr>
-          <p:cNvPr id="7" name="Rectangle 6"/>
-          <p:cNvSpPr/>
-          <p:nvPr/>
-        </p:nvSpPr>
-        <p:spPr>
-          <a:xfrm>
-            <a:off x="8046720" y="1645920"/>
-            <a:ext cx="3383280" cy="4389120"/>
-          </a:xfrm>
-          <a:prstGeom prst="rect">
-            <a:avLst/>
-          </a:prstGeom>
-          <a:solidFill>
-            <a:srgbClr val="111827"/>
-          </a:solidFill>
-          <a:ln w="19050">
-            <a:solidFill>
-              <a:srgbClr val="6366F1"/>
-            </a:solidFill>
-          </a:ln>
-        </p:spPr>
-        <p:style>
-          <a:lnRef idx="1">
-            <a:schemeClr val="accent1"/>
-          </a:lnRef>
-          <a:fillRef idx="3">
-            <a:schemeClr val="accent1"/>
-          </a:fillRef>
-          <a:effectRef idx="2">
-            <a:schemeClr val="accent1"/>
-          </a:effectRef>
-          <a:fontRef idx="minor">
-            <a:schemeClr val="lt1"/>
-          </a:fontRef>
-        </p:style>
-        <p:txBody>
-          <a:bodyPr rtlCol="0" anchor="ctr" wrap="square" lIns="182880" tIns="182880" rIns="182880" bIns="182880"/>
-          <a:lstStyle/>
-          <a:p>
-            <a:pPr algn="ctr">
-              <a:spcAft>
-                <a:spcPts val="1200"/>
-              </a:spcAft>
-              <a:defRPr sz="1800" b="1">
-                <a:solidFill>
-                  <a:srgbClr val="10B981"/>
-                </a:solidFill>
-                <a:latin typeface="Trebuchet MS"/>
-              </a:defRPr>
-            </a:pPr>
-            <a:r>
-              <a:t>Custom Categories &amp; Profile</a:t>
-            </a:r>
-          </a:p>
-          <a:p>
-            <a:pPr>
-              <a:spcAft>
-                <a:spcPts val="600"/>
-              </a:spcAft>
-              <a:defRPr sz="1300">
-                <a:solidFill>
-                  <a:srgbClr val="F8FAFC"/>
-                </a:solidFill>
-                <a:latin typeface="Calibri"/>
-              </a:defRPr>
-            </a:pPr>
-            <a:r>
-              <a:t>• Profile Avatar: Upload custom profile photos displayed on the settings page and navbar greeting.</a:t>
-            </a:r>
-          </a:p>
-          <a:p>
-            <a:pPr>
-              <a:spcAft>
-                <a:spcPts val="600"/>
-              </a:spcAft>
-              <a:defRPr sz="1300">
-                <a:solidFill>
-                  <a:srgbClr val="F8FAFC"/>
-                </a:solidFill>
-                <a:latin typeface="Calibri"/>
-              </a:defRPr>
-            </a:pPr>
-            <a:r>
-              <a:t>• Category Manager: Create custom tags (e.g. Gifts, Charity) which map directly to dropdown options.</a:t>
+                  <a:srgbClr val="64748B"/>
+                </a:solidFill>
+                <a:latin typeface="Inter"/>
+              </a:defRPr>
+            </a:pPr>
+            <a:r>
+              <a:t>▪  Advanced Filter Engine: Sort ledger data by category, type (income/expense), dates, and search descriptions.</a:t>
             </a:r>
           </a:p>
         </p:txBody>
@@ -5147,7 +5165,7 @@
     <p:bg>
       <p:bgPr>
         <a:solidFill>
-          <a:srgbClr val="090D16"/>
+          <a:srgbClr val="0F172A"/>
         </a:solidFill>
         <a:effectLst/>
       </p:bgPr>
@@ -5167,8 +5185,8 @@
         </p:nvSpPr>
         <p:spPr>
           <a:xfrm>
-            <a:off x="731520" y="365760"/>
-            <a:ext cx="10698480" cy="365760"/>
+            <a:off x="731520" y="457200"/>
+            <a:ext cx="10698480" cy="1097280"/>
           </a:xfrm>
           <a:prstGeom prst="rect">
             <a:avLst/>
@@ -5176,21 +5194,37 @@
           <a:noFill/>
         </p:spPr>
         <p:txBody>
-          <a:bodyPr wrap="none">
+          <a:bodyPr wrap="square" lIns="0" tIns="0" rIns="0" bIns="0">
             <a:spAutoFit/>
           </a:bodyPr>
           <a:lstStyle/>
           <a:p>
             <a:pPr>
-              <a:defRPr sz="1100" b="1">
-                <a:solidFill>
-                  <a:srgbClr val="6366F1"/>
-                </a:solidFill>
-                <a:latin typeface="Trebuchet MS"/>
-              </a:defRPr>
-            </a:pPr>
-            <a:r>
-              <a:t>EXPENSETRACKER FEATURES</a:t>
+              <a:spcAft>
+                <a:spcPts val="400"/>
+              </a:spcAft>
+              <a:defRPr sz="1000" b="1">
+                <a:solidFill>
+                  <a:srgbClr val="10B981"/>
+                </a:solidFill>
+                <a:latin typeface="Outfit"/>
+              </a:defRPr>
+            </a:pPr>
+            <a:r>
+              <a:t>06. THRESHOLD MANAGEMENT</a:t>
+            </a:r>
+          </a:p>
+          <a:p>
+            <a:pPr>
+              <a:defRPr sz="2800" b="1">
+                <a:solidFill>
+                  <a:srgbClr val="F8FAFC"/>
+                </a:solidFill>
+                <a:latin typeface="Outfit"/>
+              </a:defRPr>
+            </a:pPr>
+            <a:r>
+              <a:t>Budgets &amp; Warnings Engine</a:t>
             </a:r>
           </a:p>
         </p:txBody>
@@ -5203,8 +5237,8 @@
         </p:nvSpPr>
         <p:spPr>
           <a:xfrm>
-            <a:off x="731520" y="640080"/>
-            <a:ext cx="10698480" cy="731520"/>
+            <a:off x="731520" y="1828800"/>
+            <a:ext cx="10698480" cy="4114800"/>
           </a:xfrm>
           <a:prstGeom prst="rect">
             <a:avLst/>
@@ -5212,276 +5246,88 @@
           <a:noFill/>
         </p:spPr>
         <p:txBody>
-          <a:bodyPr wrap="none">
+          <a:bodyPr wrap="square">
             <a:spAutoFit/>
           </a:bodyPr>
           <a:lstStyle/>
           <a:p>
             <a:pPr>
-              <a:defRPr sz="2800" b="1">
+              <a:spcAft>
+                <a:spcPts val="1600"/>
+              </a:spcAft>
+              <a:defRPr sz="1400">
                 <a:solidFill>
                   <a:srgbClr val="F8FAFC"/>
                 </a:solidFill>
-                <a:latin typeface="Trebuchet MS"/>
-              </a:defRPr>
-            </a:pPr>
-            <a:r>
-              <a:t>Notification Alerts Center</a:t>
-            </a:r>
-          </a:p>
-        </p:txBody>
-      </p:sp>
-      <p:sp>
-        <p:nvSpPr>
-          <p:cNvPr id="4" name="Rectangle 3"/>
-          <p:cNvSpPr/>
-          <p:nvPr/>
-        </p:nvSpPr>
-        <p:spPr>
-          <a:xfrm>
-            <a:off x="731520" y="1371600"/>
-            <a:ext cx="10698480" cy="36576"/>
-          </a:xfrm>
-          <a:prstGeom prst="rect">
-            <a:avLst/>
-          </a:prstGeom>
-          <a:solidFill>
-            <a:srgbClr val="10B981"/>
-          </a:solidFill>
-          <a:ln>
-            <a:noFill/>
-          </a:ln>
-        </p:spPr>
-        <p:style>
-          <a:lnRef idx="1">
-            <a:schemeClr val="accent1"/>
-          </a:lnRef>
-          <a:fillRef idx="3">
-            <a:schemeClr val="accent1"/>
-          </a:fillRef>
-          <a:effectRef idx="2">
-            <a:schemeClr val="accent1"/>
-          </a:effectRef>
-          <a:fontRef idx="minor">
-            <a:schemeClr val="lt1"/>
-          </a:fontRef>
-        </p:style>
-        <p:txBody>
-          <a:bodyPr rtlCol="0" anchor="ctr"/>
-          <a:lstStyle/>
-          <a:p>
-            <a:pPr algn="ctr"/>
-          </a:p>
-        </p:txBody>
-      </p:sp>
-      <p:sp>
-        <p:nvSpPr>
-          <p:cNvPr id="5" name="Rectangle 4"/>
-          <p:cNvSpPr/>
-          <p:nvPr/>
-        </p:nvSpPr>
-        <p:spPr>
-          <a:xfrm>
-            <a:off x="731520" y="1645920"/>
-            <a:ext cx="5120640" cy="4389120"/>
-          </a:xfrm>
-          <a:prstGeom prst="rect">
-            <a:avLst/>
-          </a:prstGeom>
-          <a:solidFill>
-            <a:srgbClr val="111827"/>
-          </a:solidFill>
-          <a:ln w="19050">
-            <a:solidFill>
-              <a:srgbClr val="10B981"/>
-            </a:solidFill>
-          </a:ln>
-        </p:spPr>
-        <p:style>
-          <a:lnRef idx="1">
-            <a:schemeClr val="accent1"/>
-          </a:lnRef>
-          <a:fillRef idx="3">
-            <a:schemeClr val="accent1"/>
-          </a:fillRef>
-          <a:effectRef idx="2">
-            <a:schemeClr val="accent1"/>
-          </a:effectRef>
-          <a:fontRef idx="minor">
-            <a:schemeClr val="lt1"/>
-          </a:fontRef>
-        </p:style>
-        <p:txBody>
-          <a:bodyPr rtlCol="0" anchor="ctr" wrap="square" lIns="182880" tIns="182880" rIns="182880" bIns="182880"/>
-          <a:lstStyle/>
-          <a:p>
-            <a:pPr algn="ctr">
-              <a:spcAft>
-                <a:spcPts val="1200"/>
-              </a:spcAft>
-              <a:defRPr sz="1800" b="1">
-                <a:solidFill>
-                  <a:srgbClr val="10B981"/>
-                </a:solidFill>
-                <a:latin typeface="Trebuchet MS"/>
-              </a:defRPr>
-            </a:pPr>
-            <a:r>
-              <a:t>In-App Alerts Logs</a:t>
-            </a:r>
-          </a:p>
-          <a:p>
-            <a:pPr>
-              <a:spcAft>
-                <a:spcPts val="600"/>
+                <a:latin typeface="Inter"/>
+              </a:defRPr>
+            </a:pPr>
+            <a:r>
+              <a:t>To keep users aligned with their financial goals, the platform features a responsive warnings engine:</a:t>
+            </a:r>
+          </a:p>
+          <a:p>
+            <a:pPr>
+              <a:spcAft>
+                <a:spcPts val="1000"/>
               </a:spcAft>
               <a:defRPr sz="1300">
                 <a:solidFill>
-                  <a:srgbClr val="F8FAFC"/>
-                </a:solidFill>
-                <a:latin typeface="Calibri"/>
-              </a:defRPr>
-            </a:pPr>
-            <a:r>
-              <a:t>• Bell center dropdown: Easily view all active alerts on the navbar from any page.</a:t>
-            </a:r>
-          </a:p>
-          <a:p>
-            <a:pPr>
-              <a:spcAft>
-                <a:spcPts val="600"/>
+                  <a:srgbClr val="94A3B8"/>
+                </a:solidFill>
+                <a:latin typeface="Inter"/>
+              </a:defRPr>
+            </a:pPr>
+            <a:r>
+              <a:t>★  Category Budgets: Establish monthly limits for categories (Food, Bills, Shopping, Travel, etc.) to control overspending.</a:t>
+            </a:r>
+          </a:p>
+          <a:p>
+            <a:pPr>
+              <a:spcAft>
+                <a:spcPts val="1000"/>
               </a:spcAft>
               <a:defRPr sz="1300">
                 <a:solidFill>
-                  <a:srgbClr val="F8FAFC"/>
-                </a:solidFill>
-                <a:latin typeface="Calibri"/>
-              </a:defRPr>
-            </a:pPr>
-            <a:r>
-              <a:t>• Alert types: Distinguishes items visually (Success: green, Info: blue, Warning: yellow, Danger: red).</a:t>
-            </a:r>
-          </a:p>
-        </p:txBody>
-      </p:sp>
-      <p:sp>
-        <p:nvSpPr>
-          <p:cNvPr id="6" name="Rectangle 5"/>
-          <p:cNvSpPr/>
-          <p:nvPr/>
-        </p:nvSpPr>
-        <p:spPr>
-          <a:xfrm>
-            <a:off x="6217920" y="1645920"/>
-            <a:ext cx="5212080" cy="4389120"/>
-          </a:xfrm>
-          <a:prstGeom prst="rect">
-            <a:avLst/>
-          </a:prstGeom>
-          <a:solidFill>
-            <a:srgbClr val="111827"/>
-          </a:solidFill>
-          <a:ln w="19050">
-            <a:solidFill>
-              <a:srgbClr val="6366F1"/>
-            </a:solidFill>
-          </a:ln>
-        </p:spPr>
-        <p:style>
-          <a:lnRef idx="1">
-            <a:schemeClr val="accent1"/>
-          </a:lnRef>
-          <a:fillRef idx="3">
-            <a:schemeClr val="accent1"/>
-          </a:fillRef>
-          <a:effectRef idx="2">
-            <a:schemeClr val="accent1"/>
-          </a:effectRef>
-          <a:fontRef idx="minor">
-            <a:schemeClr val="lt1"/>
-          </a:fontRef>
-        </p:style>
-        <p:txBody>
-          <a:bodyPr rtlCol="0" anchor="ctr" wrap="square" lIns="182880" tIns="182880" rIns="182880" bIns="182880"/>
-          <a:lstStyle/>
-          <a:p>
-            <a:pPr algn="ctr">
-              <a:spcAft>
-                <a:spcPts val="1200"/>
-              </a:spcAft>
-              <a:defRPr sz="1800" b="1">
-                <a:solidFill>
-                  <a:srgbClr val="10B981"/>
-                </a:solidFill>
-                <a:latin typeface="Trebuchet MS"/>
-              </a:defRPr>
-            </a:pPr>
-            <a:r>
-              <a:t>Dynamic Rule Checks</a:t>
-            </a:r>
-          </a:p>
-          <a:p>
-            <a:pPr>
-              <a:spcAft>
-                <a:spcPts val="600"/>
+                  <a:srgbClr val="94A3B8"/>
+                </a:solidFill>
+                <a:latin typeface="Inter"/>
+              </a:defRPr>
+            </a:pPr>
+            <a:r>
+              <a:t>★  Custom Warning Thresholds: Set customized alert triggers (e.g. 80% or 90% of budget) using an interactive slider.</a:t>
+            </a:r>
+          </a:p>
+          <a:p>
+            <a:pPr>
+              <a:spcAft>
+                <a:spcPts val="1000"/>
               </a:spcAft>
               <a:defRPr sz="1300">
                 <a:solidFill>
-                  <a:srgbClr val="F8FAFC"/>
-                </a:solidFill>
-                <a:latin typeface="Calibri"/>
-              </a:defRPr>
-            </a:pPr>
-            <a:r>
-              <a:t>• Daily reminders: Reminds users to log entries if no transaction exists for today.</a:t>
-            </a:r>
-          </a:p>
-          <a:p>
-            <a:pPr>
-              <a:spcAft>
-                <a:spcPts val="600"/>
+                  <a:srgbClr val="94A3B8"/>
+                </a:solidFill>
+                <a:latin typeface="Inter"/>
+              </a:defRPr>
+            </a:pPr>
+            <a:r>
+              <a:t>★  Real-Time Alerts: Highlights 'Over Limit' badges on reports table, flashes warnings on the dashboard, and outputs alerts in the navbar dropdown.</a:t>
+            </a:r>
+          </a:p>
+          <a:p>
+            <a:pPr>
+              <a:spcAft>
+                <a:spcPts val="1000"/>
               </a:spcAft>
               <a:defRPr sz="1300">
                 <a:solidFill>
-                  <a:srgbClr val="F8FAFC"/>
-                </a:solidFill>
-                <a:latin typeface="Calibri"/>
-              </a:defRPr>
-            </a:pPr>
-            <a:r>
-              <a:t>• Weekly Spending summary: Displays a weekly spend rollup calculated over the last 7 days.</a:t>
-            </a:r>
-          </a:p>
-          <a:p>
-            <a:pPr>
-              <a:spcAft>
-                <a:spcPts val="600"/>
-              </a:spcAft>
-              <a:defRPr sz="1300">
-                <a:solidFill>
-                  <a:srgbClr val="F8FAFC"/>
-                </a:solidFill>
-                <a:latin typeface="Calibri"/>
-              </a:defRPr>
-            </a:pPr>
-            <a:r>
-              <a:t>• Budget warnings: Alerts when spending reaches the user's warning threshold (e.g. 90%).</a:t>
-            </a:r>
-          </a:p>
-          <a:p>
-            <a:pPr>
-              <a:spcAft>
-                <a:spcPts val="600"/>
-              </a:spcAft>
-              <a:defRPr sz="1300">
-                <a:solidFill>
-                  <a:srgbClr val="F8FAFC"/>
-                </a:solidFill>
-                <a:latin typeface="Calibri"/>
-              </a:defRPr>
-            </a:pPr>
-            <a:r>
-              <a:t>• Savings milestones: Congratulates users as net savings cross major thresholds (5k, 10k, 50k, 100k).</a:t>
+                  <a:srgbClr val="94A3B8"/>
+                </a:solidFill>
+                <a:latin typeface="Inter"/>
+              </a:defRPr>
+            </a:pPr>
+            <a:r>
+              <a:t>★  Savings Milestone Tracking: Visual milestones indicating budget status and monthly net-savings percentage achievements.</a:t>
             </a:r>
           </a:p>
         </p:txBody>
@@ -5500,7 +5346,7 @@
     <p:bg>
       <p:bgPr>
         <a:solidFill>
-          <a:srgbClr val="090D16"/>
+          <a:srgbClr val="F8FAFC"/>
         </a:solidFill>
         <a:effectLst/>
       </p:bgPr>
@@ -5520,8 +5366,8 @@
         </p:nvSpPr>
         <p:spPr>
           <a:xfrm>
-            <a:off x="731520" y="365760"/>
-            <a:ext cx="10698480" cy="365760"/>
+            <a:off x="731520" y="457200"/>
+            <a:ext cx="10698480" cy="1097280"/>
           </a:xfrm>
           <a:prstGeom prst="rect">
             <a:avLst/>
@@ -5529,21 +5375,37 @@
           <a:noFill/>
         </p:spPr>
         <p:txBody>
-          <a:bodyPr wrap="none">
+          <a:bodyPr wrap="square" lIns="0" tIns="0" rIns="0" bIns="0">
             <a:spAutoFit/>
           </a:bodyPr>
           <a:lstStyle/>
           <a:p>
             <a:pPr>
-              <a:defRPr sz="1100" b="1">
+              <a:spcAft>
+                <a:spcPts val="400"/>
+              </a:spcAft>
+              <a:defRPr sz="1000" b="1">
                 <a:solidFill>
                   <a:srgbClr val="6366F1"/>
                 </a:solidFill>
-                <a:latin typeface="Trebuchet MS"/>
-              </a:defRPr>
-            </a:pPr>
-            <a:r>
-              <a:t>EXPENSETRACKER FEATURES</a:t>
+                <a:latin typeface="Outfit"/>
+              </a:defRPr>
+            </a:pPr>
+            <a:r>
+              <a:t>07. FINANCIAL INTELLIGENCE</a:t>
+            </a:r>
+          </a:p>
+          <a:p>
+            <a:pPr>
+              <a:defRPr sz="2800" b="1">
+                <a:solidFill>
+                  <a:srgbClr val="0F172A"/>
+                </a:solidFill>
+                <a:latin typeface="Outfit"/>
+              </a:defRPr>
+            </a:pPr>
+            <a:r>
+              <a:t>Visual Analytics &amp; Dashboard</a:t>
             </a:r>
           </a:p>
         </p:txBody>
@@ -5556,8 +5418,8 @@
         </p:nvSpPr>
         <p:spPr>
           <a:xfrm>
-            <a:off x="731520" y="640080"/>
-            <a:ext cx="10698480" cy="731520"/>
+            <a:off x="731520" y="1828800"/>
+            <a:ext cx="10698480" cy="4114800"/>
           </a:xfrm>
           <a:prstGeom prst="rect">
             <a:avLst/>
@@ -5565,276 +5427,88 @@
           <a:noFill/>
         </p:spPr>
         <p:txBody>
-          <a:bodyPr wrap="none">
+          <a:bodyPr wrap="square">
             <a:spAutoFit/>
           </a:bodyPr>
           <a:lstStyle/>
           <a:p>
             <a:pPr>
-              <a:defRPr sz="2800" b="1">
-                <a:solidFill>
-                  <a:srgbClr val="F8FAFC"/>
-                </a:solidFill>
-                <a:latin typeface="Trebuchet MS"/>
-              </a:defRPr>
-            </a:pPr>
-            <a:r>
-              <a:t>Financial Analytics &amp; Export Reports</a:t>
-            </a:r>
-          </a:p>
-        </p:txBody>
-      </p:sp>
-      <p:sp>
-        <p:nvSpPr>
-          <p:cNvPr id="4" name="Rectangle 3"/>
-          <p:cNvSpPr/>
-          <p:nvPr/>
-        </p:nvSpPr>
-        <p:spPr>
-          <a:xfrm>
-            <a:off x="731520" y="1371600"/>
-            <a:ext cx="10698480" cy="36576"/>
-          </a:xfrm>
-          <a:prstGeom prst="rect">
-            <a:avLst/>
-          </a:prstGeom>
-          <a:solidFill>
-            <a:srgbClr val="10B981"/>
-          </a:solidFill>
-          <a:ln>
-            <a:noFill/>
-          </a:ln>
-        </p:spPr>
-        <p:style>
-          <a:lnRef idx="1">
-            <a:schemeClr val="accent1"/>
-          </a:lnRef>
-          <a:fillRef idx="3">
-            <a:schemeClr val="accent1"/>
-          </a:fillRef>
-          <a:effectRef idx="2">
-            <a:schemeClr val="accent1"/>
-          </a:effectRef>
-          <a:fontRef idx="minor">
-            <a:schemeClr val="lt1"/>
-          </a:fontRef>
-        </p:style>
-        <p:txBody>
-          <a:bodyPr rtlCol="0" anchor="ctr"/>
-          <a:lstStyle/>
-          <a:p>
-            <a:pPr algn="ctr"/>
-          </a:p>
-        </p:txBody>
-      </p:sp>
-      <p:sp>
-        <p:nvSpPr>
-          <p:cNvPr id="5" name="Rectangle 4"/>
-          <p:cNvSpPr/>
-          <p:nvPr/>
-        </p:nvSpPr>
-        <p:spPr>
-          <a:xfrm>
-            <a:off x="731520" y="1645920"/>
-            <a:ext cx="5120640" cy="4389120"/>
-          </a:xfrm>
-          <a:prstGeom prst="rect">
-            <a:avLst/>
-          </a:prstGeom>
-          <a:solidFill>
-            <a:srgbClr val="111827"/>
-          </a:solidFill>
-          <a:ln w="19050">
-            <a:solidFill>
-              <a:srgbClr val="6366F1"/>
-            </a:solidFill>
-          </a:ln>
-        </p:spPr>
-        <p:style>
-          <a:lnRef idx="1">
-            <a:schemeClr val="accent1"/>
-          </a:lnRef>
-          <a:fillRef idx="3">
-            <a:schemeClr val="accent1"/>
-          </a:fillRef>
-          <a:effectRef idx="2">
-            <a:schemeClr val="accent1"/>
-          </a:effectRef>
-          <a:fontRef idx="minor">
-            <a:schemeClr val="lt1"/>
-          </a:fontRef>
-        </p:style>
-        <p:txBody>
-          <a:bodyPr rtlCol="0" anchor="ctr" wrap="square" lIns="182880" tIns="182880" rIns="182880" bIns="182880"/>
-          <a:lstStyle/>
-          <a:p>
-            <a:pPr algn="ctr">
-              <a:spcAft>
-                <a:spcPts val="1200"/>
-              </a:spcAft>
-              <a:defRPr sz="1800" b="1">
-                <a:solidFill>
-                  <a:srgbClr val="10B981"/>
-                </a:solidFill>
-                <a:latin typeface="Trebuchet MS"/>
-              </a:defRPr>
-            </a:pPr>
-            <a:r>
-              <a:t>Interactive Analytical Charts</a:t>
-            </a:r>
-          </a:p>
-          <a:p>
-            <a:pPr>
-              <a:spcAft>
-                <a:spcPts val="600"/>
+              <a:spcAft>
+                <a:spcPts val="1600"/>
+              </a:spcAft>
+              <a:defRPr sz="1400">
+                <a:solidFill>
+                  <a:srgbClr val="0F172A"/>
+                </a:solidFill>
+                <a:latin typeface="Inter"/>
+              </a:defRPr>
+            </a:pPr>
+            <a:r>
+              <a:t>Data visualization transforms numbers into decisions. Chart.js powers client-side interactive rendering:</a:t>
+            </a:r>
+          </a:p>
+          <a:p>
+            <a:pPr>
+              <a:spcAft>
+                <a:spcPts val="1000"/>
               </a:spcAft>
               <a:defRPr sz="1300">
                 <a:solidFill>
-                  <a:srgbClr val="F8FAFC"/>
-                </a:solidFill>
-                <a:latin typeface="Calibri"/>
-              </a:defRPr>
-            </a:pPr>
-            <a:r>
-              <a:t>• Category breakdown: Doughnut chart plotting expense distributions across categories.</a:t>
-            </a:r>
-          </a:p>
-          <a:p>
-            <a:pPr>
-              <a:spcAft>
-                <a:spcPts val="600"/>
+                  <a:srgbClr val="64748B"/>
+                </a:solidFill>
+                <a:latin typeface="Inter"/>
+              </a:defRPr>
+            </a:pPr>
+            <a:r>
+              <a:t>✓  Category Spending Doughnut Chart: Interactive proportions displaying category percentages on hover.</a:t>
+            </a:r>
+          </a:p>
+          <a:p>
+            <a:pPr>
+              <a:spcAft>
+                <a:spcPts val="1000"/>
               </a:spcAft>
               <a:defRPr sz="1300">
                 <a:solidFill>
-                  <a:srgbClr val="F8FAFC"/>
-                </a:solidFill>
-                <a:latin typeface="Calibri"/>
-              </a:defRPr>
-            </a:pPr>
-            <a:r>
-              <a:t>• Temporal Trends: 6-month historical bar chart mapping comparative income vs expense trends.</a:t>
-            </a:r>
-          </a:p>
-          <a:p>
-            <a:pPr>
-              <a:spcAft>
-                <a:spcPts val="600"/>
+                  <a:srgbClr val="64748B"/>
+                </a:solidFill>
+                <a:latin typeface="Inter"/>
+              </a:defRPr>
+            </a:pPr>
+            <a:r>
+              <a:t>✓  Temporal Spends Bar Chart: Monthly trends tracking income vs expense comparison over time.</a:t>
+            </a:r>
+          </a:p>
+          <a:p>
+            <a:pPr>
+              <a:spcAft>
+                <a:spcPts val="1000"/>
               </a:spcAft>
               <a:defRPr sz="1300">
                 <a:solidFill>
-                  <a:srgbClr val="F8FAFC"/>
-                </a:solidFill>
-                <a:latin typeface="Calibri"/>
-              </a:defRPr>
-            </a:pPr>
-            <a:r>
-              <a:t>• Chart.js Tooltips: Interactive labels displaying dynamic currencies ($, ₹, etc.).</a:t>
-            </a:r>
-          </a:p>
-        </p:txBody>
-      </p:sp>
-      <p:sp>
-        <p:nvSpPr>
-          <p:cNvPr id="6" name="Rectangle 5"/>
-          <p:cNvSpPr/>
-          <p:nvPr/>
-        </p:nvSpPr>
-        <p:spPr>
-          <a:xfrm>
-            <a:off x="6217920" y="1645920"/>
-            <a:ext cx="5212080" cy="4389120"/>
-          </a:xfrm>
-          <a:prstGeom prst="rect">
-            <a:avLst/>
-          </a:prstGeom>
-          <a:solidFill>
-            <a:srgbClr val="111827"/>
-          </a:solidFill>
-          <a:ln w="19050">
-            <a:solidFill>
-              <a:srgbClr val="10B981"/>
-            </a:solidFill>
-          </a:ln>
-        </p:spPr>
-        <p:style>
-          <a:lnRef idx="1">
-            <a:schemeClr val="accent1"/>
-          </a:lnRef>
-          <a:fillRef idx="3">
-            <a:schemeClr val="accent1"/>
-          </a:fillRef>
-          <a:effectRef idx="2">
-            <a:schemeClr val="accent1"/>
-          </a:effectRef>
-          <a:fontRef idx="minor">
-            <a:schemeClr val="lt1"/>
-          </a:fontRef>
-        </p:style>
-        <p:txBody>
-          <a:bodyPr rtlCol="0" anchor="ctr" wrap="square" lIns="182880" tIns="182880" rIns="182880" bIns="182880"/>
-          <a:lstStyle/>
-          <a:p>
-            <a:pPr algn="ctr">
-              <a:spcAft>
-                <a:spcPts val="1200"/>
-              </a:spcAft>
-              <a:defRPr sz="1800" b="1">
-                <a:solidFill>
-                  <a:srgbClr val="10B981"/>
-                </a:solidFill>
-                <a:latin typeface="Trebuchet MS"/>
-              </a:defRPr>
-            </a:pPr>
-            <a:r>
-              <a:t>CSV &amp; ReportLab PDF Exports</a:t>
-            </a:r>
-          </a:p>
-          <a:p>
-            <a:pPr>
-              <a:spcAft>
-                <a:spcPts val="600"/>
+                  <a:srgbClr val="64748B"/>
+                </a:solidFill>
+                <a:latin typeface="Inter"/>
+              </a:defRPr>
+            </a:pPr>
+            <a:r>
+              <a:t>✓  Responsive Mode Rendering: JavaScript helpers re-render Chart.js colors to adapt dynamically to Dark Mode and Light Mode theme switches.</a:t>
+            </a:r>
+          </a:p>
+          <a:p>
+            <a:pPr>
+              <a:spcAft>
+                <a:spcPts val="1000"/>
               </a:spcAft>
               <a:defRPr sz="1300">
                 <a:solidFill>
-                  <a:srgbClr val="F8FAFC"/>
-                </a:solidFill>
-                <a:latin typeface="Calibri"/>
-              </a:defRPr>
-            </a:pPr>
-            <a:r>
-              <a:t>• Monthly filters: Generate detailed reports filtered by calendar month.</a:t>
-            </a:r>
-          </a:p>
-          <a:p>
-            <a:pPr>
-              <a:spcAft>
-                <a:spcPts val="600"/>
-              </a:spcAft>
-              <a:defRPr sz="1300">
-                <a:solidFill>
-                  <a:srgbClr val="F8FAFC"/>
-                </a:solidFill>
-                <a:latin typeface="Calibri"/>
-              </a:defRPr>
-            </a:pPr>
-            <a:r>
-              <a:t>• CSV Spreadsheet: Exports raw transaction logs, compatible with Excel or Google Sheets.</a:t>
-            </a:r>
-          </a:p>
-          <a:p>
-            <a:pPr>
-              <a:spcAft>
-                <a:spcPts val="600"/>
-              </a:spcAft>
-              <a:defRPr sz="1300">
-                <a:solidFill>
-                  <a:srgbClr val="F8FAFC"/>
-                </a:solidFill>
-                <a:latin typeface="Calibri"/>
-              </a:defRPr>
-            </a:pPr>
-            <a:r>
-              <a:t>• ReportLab PDF Report: Generates premium business PDF summaries, including stats cards, category limits, status, and transaction tables with dynamic currency headers.</a:t>
+                  <a:srgbClr val="64748B"/>
+                </a:solidFill>
+                <a:latin typeface="Inter"/>
+              </a:defRPr>
+            </a:pPr>
+            <a:r>
+              <a:t>✓  Accents Integration: Colors automatically scale to fit selected theme swatches (Indigo, Emerald, Rose, Amber, Blue).</a:t>
             </a:r>
           </a:p>
         </p:txBody>
@@ -5853,7 +5527,7 @@
     <p:bg>
       <p:bgPr>
         <a:solidFill>
-          <a:srgbClr val="090D16"/>
+          <a:srgbClr val="0F172A"/>
         </a:solidFill>
         <a:effectLst/>
       </p:bgPr>
@@ -5873,8 +5547,8 @@
         </p:nvSpPr>
         <p:spPr>
           <a:xfrm>
-            <a:off x="731520" y="365760"/>
-            <a:ext cx="10698480" cy="365760"/>
+            <a:off x="731520" y="457200"/>
+            <a:ext cx="10698480" cy="1097280"/>
           </a:xfrm>
           <a:prstGeom prst="rect">
             <a:avLst/>
@@ -5882,21 +5556,37 @@
           <a:noFill/>
         </p:spPr>
         <p:txBody>
-          <a:bodyPr wrap="none">
+          <a:bodyPr wrap="square" lIns="0" tIns="0" rIns="0" bIns="0">
             <a:spAutoFit/>
           </a:bodyPr>
           <a:lstStyle/>
           <a:p>
             <a:pPr>
-              <a:defRPr sz="1100" b="1">
-                <a:solidFill>
-                  <a:srgbClr val="6366F1"/>
-                </a:solidFill>
-                <a:latin typeface="Trebuchet MS"/>
-              </a:defRPr>
-            </a:pPr>
-            <a:r>
-              <a:t>EXPENSETRACKER FEATURES</a:t>
+              <a:spcAft>
+                <a:spcPts val="400"/>
+              </a:spcAft>
+              <a:defRPr sz="1000" b="1">
+                <a:solidFill>
+                  <a:srgbClr val="10B981"/>
+                </a:solidFill>
+                <a:latin typeface="Outfit"/>
+              </a:defRPr>
+            </a:pPr>
+            <a:r>
+              <a:t>08. EXPORT ENGINE</a:t>
+            </a:r>
+          </a:p>
+          <a:p>
+            <a:pPr>
+              <a:defRPr sz="2800" b="1">
+                <a:solidFill>
+                  <a:srgbClr val="F8FAFC"/>
+                </a:solidFill>
+                <a:latin typeface="Outfit"/>
+              </a:defRPr>
+            </a:pPr>
+            <a:r>
+              <a:t>Reporting &amp; Statement Exporters</a:t>
             </a:r>
           </a:p>
         </p:txBody>
@@ -5909,8 +5599,8 @@
         </p:nvSpPr>
         <p:spPr>
           <a:xfrm>
-            <a:off x="731520" y="640080"/>
-            <a:ext cx="10698480" cy="731520"/>
+            <a:off x="731520" y="1828800"/>
+            <a:ext cx="10698480" cy="4114800"/>
           </a:xfrm>
           <a:prstGeom prst="rect">
             <a:avLst/>
@@ -5918,398 +5608,88 @@
           <a:noFill/>
         </p:spPr>
         <p:txBody>
-          <a:bodyPr wrap="none">
+          <a:bodyPr wrap="square">
             <a:spAutoFit/>
           </a:bodyPr>
           <a:lstStyle/>
           <a:p>
             <a:pPr>
-              <a:defRPr sz="2800" b="1">
+              <a:spcAft>
+                <a:spcPts val="1600"/>
+              </a:spcAft>
+              <a:defRPr sz="1400">
                 <a:solidFill>
                   <a:srgbClr val="F8FAFC"/>
                 </a:solidFill>
-                <a:latin typeface="Trebuchet MS"/>
-              </a:defRPr>
-            </a:pPr>
-            <a:r>
-              <a:t>Technical Stack &amp; Architecture</a:t>
-            </a:r>
-          </a:p>
-        </p:txBody>
-      </p:sp>
-      <p:sp>
-        <p:nvSpPr>
-          <p:cNvPr id="4" name="Rectangle 3"/>
-          <p:cNvSpPr/>
-          <p:nvPr/>
-        </p:nvSpPr>
-        <p:spPr>
-          <a:xfrm>
-            <a:off x="731520" y="1371600"/>
-            <a:ext cx="10698480" cy="36576"/>
-          </a:xfrm>
-          <a:prstGeom prst="rect">
-            <a:avLst/>
-          </a:prstGeom>
-          <a:solidFill>
-            <a:srgbClr val="10B981"/>
-          </a:solidFill>
-          <a:ln>
-            <a:noFill/>
-          </a:ln>
-        </p:spPr>
-        <p:style>
-          <a:lnRef idx="1">
-            <a:schemeClr val="accent1"/>
-          </a:lnRef>
-          <a:fillRef idx="3">
-            <a:schemeClr val="accent1"/>
-          </a:fillRef>
-          <a:effectRef idx="2">
-            <a:schemeClr val="accent1"/>
-          </a:effectRef>
-          <a:fontRef idx="minor">
-            <a:schemeClr val="lt1"/>
-          </a:fontRef>
-        </p:style>
-        <p:txBody>
-          <a:bodyPr rtlCol="0" anchor="ctr"/>
-          <a:lstStyle/>
-          <a:p>
-            <a:pPr algn="ctr"/>
-          </a:p>
-        </p:txBody>
-      </p:sp>
-      <p:sp>
-        <p:nvSpPr>
-          <p:cNvPr id="5" name="Rectangle 4"/>
-          <p:cNvSpPr/>
-          <p:nvPr/>
-        </p:nvSpPr>
-        <p:spPr>
-          <a:xfrm>
-            <a:off x="731520" y="1645920"/>
-            <a:ext cx="3291840" cy="4389120"/>
-          </a:xfrm>
-          <a:prstGeom prst="rect">
-            <a:avLst/>
-          </a:prstGeom>
-          <a:solidFill>
-            <a:srgbClr val="111827"/>
-          </a:solidFill>
-          <a:ln w="19050">
-            <a:solidFill>
-              <a:srgbClr val="10B981"/>
-            </a:solidFill>
-          </a:ln>
-        </p:spPr>
-        <p:style>
-          <a:lnRef idx="1">
-            <a:schemeClr val="accent1"/>
-          </a:lnRef>
-          <a:fillRef idx="3">
-            <a:schemeClr val="accent1"/>
-          </a:fillRef>
-          <a:effectRef idx="2">
-            <a:schemeClr val="accent1"/>
-          </a:effectRef>
-          <a:fontRef idx="minor">
-            <a:schemeClr val="lt1"/>
-          </a:fontRef>
-        </p:style>
-        <p:txBody>
-          <a:bodyPr rtlCol="0" anchor="ctr" wrap="square" lIns="182880" tIns="182880" rIns="182880" bIns="182880"/>
-          <a:lstStyle/>
-          <a:p>
-            <a:pPr algn="ctr">
-              <a:spcAft>
-                <a:spcPts val="1200"/>
-              </a:spcAft>
-              <a:defRPr sz="1800" b="1">
-                <a:solidFill>
-                  <a:srgbClr val="10B981"/>
-                </a:solidFill>
-                <a:latin typeface="Trebuchet MS"/>
-              </a:defRPr>
-            </a:pPr>
-            <a:r>
-              <a:t>Backend Framework</a:t>
-            </a:r>
-          </a:p>
-          <a:p>
-            <a:pPr>
-              <a:spcAft>
-                <a:spcPts val="600"/>
+                <a:latin typeface="Inter"/>
+              </a:defRPr>
+            </a:pPr>
+            <a:r>
+              <a:t>Export statement files cleanly with maximum browser download compatibility:</a:t>
+            </a:r>
+          </a:p>
+          <a:p>
+            <a:pPr>
+              <a:spcAft>
+                <a:spcPts val="1000"/>
               </a:spcAft>
               <a:defRPr sz="1300">
                 <a:solidFill>
-                  <a:srgbClr val="F8FAFC"/>
-                </a:solidFill>
-                <a:latin typeface="Calibri"/>
-              </a:defRPr>
-            </a:pPr>
-            <a:r>
-              <a:t>• Python Flask: High-speed micro-framework routing core logical pathways.</a:t>
-            </a:r>
-          </a:p>
-          <a:p>
-            <a:pPr>
-              <a:spcAft>
-                <a:spcPts val="600"/>
+                  <a:srgbClr val="94A3B8"/>
+                </a:solidFill>
+                <a:latin typeface="Inter"/>
+              </a:defRPr>
+            </a:pPr>
+            <a:r>
+              <a:t>▪  ReportLab PDF Statements: Custom flowable layouts displaying clean typography, summarized key metrics, category analysis grids, and structured transaction detail logs.</a:t>
+            </a:r>
+          </a:p>
+          <a:p>
+            <a:pPr>
+              <a:spcAft>
+                <a:spcPts val="1000"/>
               </a:spcAft>
               <a:defRPr sz="1300">
                 <a:solidFill>
-                  <a:srgbClr val="F8FAFC"/>
-                </a:solidFill>
-                <a:latin typeface="Calibri"/>
-              </a:defRPr>
-            </a:pPr>
-            <a:r>
-              <a:t>• SQLite Database: Fast, local database backend storage.</a:t>
-            </a:r>
-          </a:p>
-          <a:p>
-            <a:pPr>
-              <a:spcAft>
-                <a:spcPts val="600"/>
+                  <a:srgbClr val="94A3B8"/>
+                </a:solidFill>
+                <a:latin typeface="Inter"/>
+              </a:defRPr>
+            </a:pPr>
+            <a:r>
+              <a:t>▪  Microsoft PowerPoint Slideshows: Python-pptx compiles widescreen slideshows containing key summaries and colored category Spent vs. Budget tables.</a:t>
+            </a:r>
+          </a:p>
+          <a:p>
+            <a:pPr>
+              <a:spcAft>
+                <a:spcPts val="1000"/>
               </a:spcAft>
               <a:defRPr sz="1300">
                 <a:solidFill>
-                  <a:srgbClr val="F8FAFC"/>
-                </a:solidFill>
-                <a:latin typeface="Calibri"/>
-              </a:defRPr>
-            </a:pPr>
-            <a:r>
-              <a:t>• SQLAlchemy ORM: Handles data object mappings and relationships.</a:t>
-            </a:r>
-          </a:p>
-          <a:p>
-            <a:pPr>
-              <a:spcAft>
-                <a:spcPts val="600"/>
+                  <a:srgbClr val="94A3B8"/>
+                </a:solidFill>
+                <a:latin typeface="Inter"/>
+              </a:defRPr>
+            </a:pPr>
+            <a:r>
+              <a:t>▪  Double-Quoted Filename Safety: Filename parameter double-quotes in Content-Disposition headers to bypass localhost download manager UUID renames.</a:t>
+            </a:r>
+          </a:p>
+          <a:p>
+            <a:pPr>
+              <a:spcAft>
+                <a:spcPts val="1000"/>
               </a:spcAft>
               <a:defRPr sz="1300">
                 <a:solidFill>
-                  <a:srgbClr val="F8FAFC"/>
-                </a:solidFill>
-                <a:latin typeface="Calibri"/>
-              </a:defRPr>
-            </a:pPr>
-            <a:r>
-              <a:t>• Flask-Login: Controls user sessions, route security, and profiles.</a:t>
-            </a:r>
-          </a:p>
-        </p:txBody>
-      </p:sp>
-      <p:sp>
-        <p:nvSpPr>
-          <p:cNvPr id="6" name="Rectangle 5"/>
-          <p:cNvSpPr/>
-          <p:nvPr/>
-        </p:nvSpPr>
-        <p:spPr>
-          <a:xfrm>
-            <a:off x="4389120" y="1645920"/>
-            <a:ext cx="3291840" cy="4389120"/>
-          </a:xfrm>
-          <a:prstGeom prst="rect">
-            <a:avLst/>
-          </a:prstGeom>
-          <a:solidFill>
-            <a:srgbClr val="111827"/>
-          </a:solidFill>
-          <a:ln w="19050">
-            <a:solidFill>
-              <a:srgbClr val="6366F1"/>
-            </a:solidFill>
-          </a:ln>
-        </p:spPr>
-        <p:style>
-          <a:lnRef idx="1">
-            <a:schemeClr val="accent1"/>
-          </a:lnRef>
-          <a:fillRef idx="3">
-            <a:schemeClr val="accent1"/>
-          </a:fillRef>
-          <a:effectRef idx="2">
-            <a:schemeClr val="accent1"/>
-          </a:effectRef>
-          <a:fontRef idx="minor">
-            <a:schemeClr val="lt1"/>
-          </a:fontRef>
-        </p:style>
-        <p:txBody>
-          <a:bodyPr rtlCol="0" anchor="ctr" wrap="square" lIns="182880" tIns="182880" rIns="182880" bIns="182880"/>
-          <a:lstStyle/>
-          <a:p>
-            <a:pPr algn="ctr">
-              <a:spcAft>
-                <a:spcPts val="1200"/>
-              </a:spcAft>
-              <a:defRPr sz="1800" b="1">
-                <a:solidFill>
-                  <a:srgbClr val="10B981"/>
-                </a:solidFill>
-                <a:latin typeface="Trebuchet MS"/>
-              </a:defRPr>
-            </a:pPr>
-            <a:r>
-              <a:t>Frontend UI &amp; Styling</a:t>
-            </a:r>
-          </a:p>
-          <a:p>
-            <a:pPr>
-              <a:spcAft>
-                <a:spcPts val="600"/>
-              </a:spcAft>
-              <a:defRPr sz="1300">
-                <a:solidFill>
-                  <a:srgbClr val="F8FAFC"/>
-                </a:solidFill>
-                <a:latin typeface="Calibri"/>
-              </a:defRPr>
-            </a:pPr>
-            <a:r>
-              <a:t>• Bootstrap 5: Flexible layout grids and interactive modals.</a:t>
-            </a:r>
-          </a:p>
-          <a:p>
-            <a:pPr>
-              <a:spcAft>
-                <a:spcPts val="600"/>
-              </a:spcAft>
-              <a:defRPr sz="1300">
-                <a:solidFill>
-                  <a:srgbClr val="F8FAFC"/>
-                </a:solidFill>
-                <a:latin typeface="Calibri"/>
-              </a:defRPr>
-            </a:pPr>
-            <a:r>
-              <a:t>• Vanilla CSS: Custom glassmorphic styling, pulse animations, and theme accents.</a:t>
-            </a:r>
-          </a:p>
-          <a:p>
-            <a:pPr>
-              <a:spcAft>
-                <a:spcPts val="600"/>
-              </a:spcAft>
-              <a:defRPr sz="1300">
-                <a:solidFill>
-                  <a:srgbClr val="F8FAFC"/>
-                </a:solidFill>
-                <a:latin typeface="Calibri"/>
-              </a:defRPr>
-            </a:pPr>
-            <a:r>
-              <a:t>• HTML5 Canvas: Floating background particles and moving wave graphics.</a:t>
-            </a:r>
-          </a:p>
-        </p:txBody>
-      </p:sp>
-      <p:sp>
-        <p:nvSpPr>
-          <p:cNvPr id="7" name="Rectangle 6"/>
-          <p:cNvSpPr/>
-          <p:nvPr/>
-        </p:nvSpPr>
-        <p:spPr>
-          <a:xfrm>
-            <a:off x="8046720" y="1645920"/>
-            <a:ext cx="3383280" cy="4389120"/>
-          </a:xfrm>
-          <a:prstGeom prst="rect">
-            <a:avLst/>
-          </a:prstGeom>
-          <a:solidFill>
-            <a:srgbClr val="111827"/>
-          </a:solidFill>
-          <a:ln w="19050">
-            <a:solidFill>
-              <a:srgbClr val="10B981"/>
-            </a:solidFill>
-          </a:ln>
-        </p:spPr>
-        <p:style>
-          <a:lnRef idx="1">
-            <a:schemeClr val="accent1"/>
-          </a:lnRef>
-          <a:fillRef idx="3">
-            <a:schemeClr val="accent1"/>
-          </a:fillRef>
-          <a:effectRef idx="2">
-            <a:schemeClr val="accent1"/>
-          </a:effectRef>
-          <a:fontRef idx="minor">
-            <a:schemeClr val="lt1"/>
-          </a:fontRef>
-        </p:style>
-        <p:txBody>
-          <a:bodyPr rtlCol="0" anchor="ctr" wrap="square" lIns="182880" tIns="182880" rIns="182880" bIns="182880"/>
-          <a:lstStyle/>
-          <a:p>
-            <a:pPr algn="ctr">
-              <a:spcAft>
-                <a:spcPts val="1200"/>
-              </a:spcAft>
-              <a:defRPr sz="1800" b="1">
-                <a:solidFill>
-                  <a:srgbClr val="10B981"/>
-                </a:solidFill>
-                <a:latin typeface="Trebuchet MS"/>
-              </a:defRPr>
-            </a:pPr>
-            <a:r>
-              <a:t>Key Assets Engines</a:t>
-            </a:r>
-          </a:p>
-          <a:p>
-            <a:pPr>
-              <a:spcAft>
-                <a:spcPts val="600"/>
-              </a:spcAft>
-              <a:defRPr sz="1300">
-                <a:solidFill>
-                  <a:srgbClr val="F8FAFC"/>
-                </a:solidFill>
-                <a:latin typeface="Calibri"/>
-              </a:defRPr>
-            </a:pPr>
-            <a:r>
-              <a:t>• Chart.js: Renders responsive data visualization canvasses.</a:t>
-            </a:r>
-          </a:p>
-          <a:p>
-            <a:pPr>
-              <a:spcAft>
-                <a:spcPts val="600"/>
-              </a:spcAft>
-              <a:defRPr sz="1300">
-                <a:solidFill>
-                  <a:srgbClr val="F8FAFC"/>
-                </a:solidFill>
-                <a:latin typeface="Calibri"/>
-              </a:defRPr>
-            </a:pPr>
-            <a:r>
-              <a:t>• ReportLab API: Direct PDF builder compiling clean business structures.</a:t>
-            </a:r>
-          </a:p>
-          <a:p>
-            <a:pPr>
-              <a:spcAft>
-                <a:spcPts val="600"/>
-              </a:spcAft>
-              <a:defRPr sz="1300">
-                <a:solidFill>
-                  <a:srgbClr val="F8FAFC"/>
-                </a:solidFill>
-                <a:latin typeface="Calibri"/>
-              </a:defRPr>
-            </a:pPr>
-            <a:r>
-              <a:t>• Werkzeug Security: Protects accounts using secure password hashing hashes.</a:t>
+                  <a:srgbClr val="94A3B8"/>
+                </a:solidFill>
+                <a:latin typeface="Inter"/>
+              </a:defRPr>
+            </a:pPr>
+            <a:r>
+              <a:t>▪  Standard CSV Outputs: Unformatted, comma-separated spreadsheets ideal for Excel and Google Sheets integration.</a:t>
             </a:r>
           </a:p>
         </p:txBody>

</xml_diff>